<commit_message>
OpenGrid MVP: AI-assisted geospatial data retrieval system
Includes: AI planning agent, multi-provider geocoding (AMap/Baidu/Nominatim), 9 data source clients, GeoJSON output pipeline, test suite, and documentation
</commit_message>
<xml_diff>
--- a/工作记录.pptx
+++ b/工作记录.pptx
@@ -2,18 +2,20 @@
 <file path=ppt/presentation.xml><?xml version="1.0" encoding="utf-8"?>
 <p:presentation xmlns:a="http://schemas.openxmlformats.org/drawingml/2006/main" xmlns:r="http://schemas.openxmlformats.org/officeDocument/2006/relationships" xmlns:p="http://schemas.openxmlformats.org/presentationml/2006/main" saveSubsetFonts="1">
   <p:sldMasterIdLst>
-    <p:sldMasterId id="2147483648" r:id="rId1"/>
+    <p:sldMasterId id="2147483672" r:id="rId1"/>
   </p:sldMasterIdLst>
   <p:sldIdLst>
     <p:sldId id="256" r:id="rId2"/>
+    <p:sldId id="257" r:id="rId3"/>
+    <p:sldId id="258" r:id="rId4"/>
   </p:sldIdLst>
   <p:sldSz cx="12192000" cy="6858000"/>
   <p:notesSz cx="6858000" cy="9144000"/>
   <p:defaultTextStyle>
     <a:defPPr>
-      <a:defRPr lang="zh-CN"/>
+      <a:defRPr lang="en-US"/>
     </a:defPPr>
-    <a:lvl1pPr marL="0" algn="l" defTabSz="914400" rtl="0" eaLnBrk="1" latinLnBrk="0" hangingPunct="1">
+    <a:lvl1pPr marL="0" algn="l" defTabSz="457200" rtl="0" eaLnBrk="1" latinLnBrk="0" hangingPunct="1">
       <a:defRPr sz="1800" kern="1200">
         <a:solidFill>
           <a:schemeClr val="tx1"/>
@@ -23,7 +25,7 @@
         <a:cs typeface="+mn-cs"/>
       </a:defRPr>
     </a:lvl1pPr>
-    <a:lvl2pPr marL="457200" algn="l" defTabSz="914400" rtl="0" eaLnBrk="1" latinLnBrk="0" hangingPunct="1">
+    <a:lvl2pPr marL="457200" algn="l" defTabSz="457200" rtl="0" eaLnBrk="1" latinLnBrk="0" hangingPunct="1">
       <a:defRPr sz="1800" kern="1200">
         <a:solidFill>
           <a:schemeClr val="tx1"/>
@@ -33,7 +35,7 @@
         <a:cs typeface="+mn-cs"/>
       </a:defRPr>
     </a:lvl2pPr>
-    <a:lvl3pPr marL="914400" algn="l" defTabSz="914400" rtl="0" eaLnBrk="1" latinLnBrk="0" hangingPunct="1">
+    <a:lvl3pPr marL="914400" algn="l" defTabSz="457200" rtl="0" eaLnBrk="1" latinLnBrk="0" hangingPunct="1">
       <a:defRPr sz="1800" kern="1200">
         <a:solidFill>
           <a:schemeClr val="tx1"/>
@@ -43,7 +45,7 @@
         <a:cs typeface="+mn-cs"/>
       </a:defRPr>
     </a:lvl3pPr>
-    <a:lvl4pPr marL="1371600" algn="l" defTabSz="914400" rtl="0" eaLnBrk="1" latinLnBrk="0" hangingPunct="1">
+    <a:lvl4pPr marL="1371600" algn="l" defTabSz="457200" rtl="0" eaLnBrk="1" latinLnBrk="0" hangingPunct="1">
       <a:defRPr sz="1800" kern="1200">
         <a:solidFill>
           <a:schemeClr val="tx1"/>
@@ -53,7 +55,7 @@
         <a:cs typeface="+mn-cs"/>
       </a:defRPr>
     </a:lvl4pPr>
-    <a:lvl5pPr marL="1828800" algn="l" defTabSz="914400" rtl="0" eaLnBrk="1" latinLnBrk="0" hangingPunct="1">
+    <a:lvl5pPr marL="1828800" algn="l" defTabSz="457200" rtl="0" eaLnBrk="1" latinLnBrk="0" hangingPunct="1">
       <a:defRPr sz="1800" kern="1200">
         <a:solidFill>
           <a:schemeClr val="tx1"/>
@@ -63,7 +65,7 @@
         <a:cs typeface="+mn-cs"/>
       </a:defRPr>
     </a:lvl5pPr>
-    <a:lvl6pPr marL="2286000" algn="l" defTabSz="914400" rtl="0" eaLnBrk="1" latinLnBrk="0" hangingPunct="1">
+    <a:lvl6pPr marL="2286000" algn="l" defTabSz="457200" rtl="0" eaLnBrk="1" latinLnBrk="0" hangingPunct="1">
       <a:defRPr sz="1800" kern="1200">
         <a:solidFill>
           <a:schemeClr val="tx1"/>
@@ -73,7 +75,7 @@
         <a:cs typeface="+mn-cs"/>
       </a:defRPr>
     </a:lvl6pPr>
-    <a:lvl7pPr marL="2743200" algn="l" defTabSz="914400" rtl="0" eaLnBrk="1" latinLnBrk="0" hangingPunct="1">
+    <a:lvl7pPr marL="2743200" algn="l" defTabSz="457200" rtl="0" eaLnBrk="1" latinLnBrk="0" hangingPunct="1">
       <a:defRPr sz="1800" kern="1200">
         <a:solidFill>
           <a:schemeClr val="tx1"/>
@@ -83,7 +85,7 @@
         <a:cs typeface="+mn-cs"/>
       </a:defRPr>
     </a:lvl7pPr>
-    <a:lvl8pPr marL="3200400" algn="l" defTabSz="914400" rtl="0" eaLnBrk="1" latinLnBrk="0" hangingPunct="1">
+    <a:lvl8pPr marL="3200400" algn="l" defTabSz="457200" rtl="0" eaLnBrk="1" latinLnBrk="0" hangingPunct="1">
       <a:defRPr sz="1800" kern="1200">
         <a:solidFill>
           <a:schemeClr val="tx1"/>
@@ -93,7 +95,7 @@
         <a:cs typeface="+mn-cs"/>
       </a:defRPr>
     </a:lvl8pPr>
-    <a:lvl9pPr marL="3657600" algn="l" defTabSz="914400" rtl="0" eaLnBrk="1" latinLnBrk="0" hangingPunct="1">
+    <a:lvl9pPr marL="3657600" algn="l" defTabSz="457200" rtl="0" eaLnBrk="1" latinLnBrk="0" hangingPunct="1">
       <a:defRPr sz="1800" kern="1200">
         <a:solidFill>
           <a:schemeClr val="tx1"/>
@@ -104,6 +106,11 @@
       </a:defRPr>
     </a:lvl9pPr>
   </p:defaultTextStyle>
+  <p:extLst>
+    <p:ext uri="{EFAFB233-063F-42B5-8137-9DF3F51BA10A}">
+      <p15:sldGuideLst xmlns:p15="http://schemas.microsoft.com/office/powerpoint/2012/main"/>
+    </p:ext>
+  </p:extLst>
 </p:presentation>
 </file>
 
@@ -126,13 +133,7 @@
       </p:grpSpPr>
       <p:sp>
         <p:nvSpPr>
-          <p:cNvPr id="2" name="标题 1">
-            <a:extLst>
-              <a:ext uri="{FF2B5EF4-FFF2-40B4-BE49-F238E27FC236}">
-                <a16:creationId xmlns:a16="http://schemas.microsoft.com/office/drawing/2014/main" id="{0E0A23F6-46C7-C671-DB69-F70B98790F83}"/>
-              </a:ext>
-            </a:extLst>
-          </p:cNvPr>
+          <p:cNvPr id="2" name="Title 1"/>
           <p:cNvSpPr>
             <a:spLocks noGrp="1"/>
           </p:cNvSpPr>
@@ -158,18 +159,13 @@
               <a:rPr lang="zh-CN" altLang="en-US"/>
               <a:t>单击此处编辑母版标题样式</a:t>
             </a:r>
-          </a:p>
-        </p:txBody>
-      </p:sp>
-      <p:sp>
-        <p:nvSpPr>
-          <p:cNvPr id="3" name="副标题 2">
-            <a:extLst>
-              <a:ext uri="{FF2B5EF4-FFF2-40B4-BE49-F238E27FC236}">
-                <a16:creationId xmlns:a16="http://schemas.microsoft.com/office/drawing/2014/main" id="{175876A3-AA65-9B0F-000D-03884DFC0314}"/>
-              </a:ext>
-            </a:extLst>
-          </p:cNvPr>
+            <a:endParaRPr lang="en-US" dirty="0"/>
+          </a:p>
+        </p:txBody>
+      </p:sp>
+      <p:sp>
+        <p:nvSpPr>
+          <p:cNvPr id="3" name="Subtitle 2"/>
           <p:cNvSpPr>
             <a:spLocks noGrp="1"/>
           </p:cNvSpPr>
@@ -228,18 +224,13 @@
               <a:rPr lang="zh-CN" altLang="en-US"/>
               <a:t>单击此处编辑母版副标题样式</a:t>
             </a:r>
-          </a:p>
-        </p:txBody>
-      </p:sp>
-      <p:sp>
-        <p:nvSpPr>
-          <p:cNvPr id="4" name="日期占位符 3">
-            <a:extLst>
-              <a:ext uri="{FF2B5EF4-FFF2-40B4-BE49-F238E27FC236}">
-                <a16:creationId xmlns:a16="http://schemas.microsoft.com/office/drawing/2014/main" id="{38D91832-D1EA-F6B0-F365-663C3F3A0016}"/>
-              </a:ext>
-            </a:extLst>
-          </p:cNvPr>
+            <a:endParaRPr lang="en-US" dirty="0"/>
+          </a:p>
+        </p:txBody>
+      </p:sp>
+      <p:sp>
+        <p:nvSpPr>
+          <p:cNvPr id="4" name="Date Placeholder 3"/>
           <p:cNvSpPr>
             <a:spLocks noGrp="1"/>
           </p:cNvSpPr>
@@ -254,7 +245,7 @@
           <a:p>
             <a:fld id="{16165D88-AD7F-4A3E-AF0D-D47865DDC7CF}" type="datetimeFigureOut">
               <a:rPr lang="zh-CN" altLang="en-US" smtClean="0"/>
-              <a:t>2026/5/8</a:t>
+              <a:t>2026/5/29</a:t>
             </a:fld>
             <a:endParaRPr lang="zh-CN" altLang="en-US"/>
           </a:p>
@@ -262,13 +253,7 @@
       </p:sp>
       <p:sp>
         <p:nvSpPr>
-          <p:cNvPr id="5" name="页脚占位符 4">
-            <a:extLst>
-              <a:ext uri="{FF2B5EF4-FFF2-40B4-BE49-F238E27FC236}">
-                <a16:creationId xmlns:a16="http://schemas.microsoft.com/office/drawing/2014/main" id="{D5E5B7A4-1A1E-F476-C61D-A478634EF22C}"/>
-              </a:ext>
-            </a:extLst>
-          </p:cNvPr>
+          <p:cNvPr id="5" name="Footer Placeholder 4"/>
           <p:cNvSpPr>
             <a:spLocks noGrp="1"/>
           </p:cNvSpPr>
@@ -287,13 +272,7 @@
       </p:sp>
       <p:sp>
         <p:nvSpPr>
-          <p:cNvPr id="6" name="灯片编号占位符 5">
-            <a:extLst>
-              <a:ext uri="{FF2B5EF4-FFF2-40B4-BE49-F238E27FC236}">
-                <a16:creationId xmlns:a16="http://schemas.microsoft.com/office/drawing/2014/main" id="{0DE6593F-8E82-3350-B78A-1D101382CD24}"/>
-              </a:ext>
-            </a:extLst>
-          </p:cNvPr>
+          <p:cNvPr id="6" name="Slide Number Placeholder 5"/>
           <p:cNvSpPr>
             <a:spLocks noGrp="1"/>
           </p:cNvSpPr>
@@ -317,7 +296,7 @@
     </p:spTree>
     <p:extLst>
       <p:ext uri="{BB962C8B-B14F-4D97-AF65-F5344CB8AC3E}">
-        <p14:creationId xmlns:p14="http://schemas.microsoft.com/office/powerpoint/2010/main" val="2940303101"/>
+        <p14:creationId xmlns:p14="http://schemas.microsoft.com/office/powerpoint/2010/main" val="2914612777"/>
       </p:ext>
     </p:extLst>
   </p:cSld>
@@ -346,13 +325,7 @@
       </p:grpSpPr>
       <p:sp>
         <p:nvSpPr>
-          <p:cNvPr id="2" name="标题 1">
-            <a:extLst>
-              <a:ext uri="{FF2B5EF4-FFF2-40B4-BE49-F238E27FC236}">
-                <a16:creationId xmlns:a16="http://schemas.microsoft.com/office/drawing/2014/main" id="{6FB02E3C-A82E-DC43-9732-6401DF1C058D}"/>
-              </a:ext>
-            </a:extLst>
-          </p:cNvPr>
+          <p:cNvPr id="2" name="Title 1"/>
           <p:cNvSpPr>
             <a:spLocks noGrp="1"/>
           </p:cNvSpPr>
@@ -369,18 +342,13 @@
               <a:rPr lang="zh-CN" altLang="en-US"/>
               <a:t>单击此处编辑母版标题样式</a:t>
             </a:r>
-          </a:p>
-        </p:txBody>
-      </p:sp>
-      <p:sp>
-        <p:nvSpPr>
-          <p:cNvPr id="3" name="竖排文字占位符 2">
-            <a:extLst>
-              <a:ext uri="{FF2B5EF4-FFF2-40B4-BE49-F238E27FC236}">
-                <a16:creationId xmlns:a16="http://schemas.microsoft.com/office/drawing/2014/main" id="{CB12D967-8D2A-53D4-F8AE-0406A554437E}"/>
-              </a:ext>
-            </a:extLst>
-          </p:cNvPr>
+            <a:endParaRPr lang="en-US" dirty="0"/>
+          </a:p>
+        </p:txBody>
+      </p:sp>
+      <p:sp>
+        <p:nvSpPr>
+          <p:cNvPr id="3" name="Vertical Text Placeholder 2"/>
           <p:cNvSpPr>
             <a:spLocks noGrp="1"/>
           </p:cNvSpPr>
@@ -426,18 +394,13 @@
               <a:rPr lang="zh-CN" altLang="en-US"/>
               <a:t>五级</a:t>
             </a:r>
-          </a:p>
-        </p:txBody>
-      </p:sp>
-      <p:sp>
-        <p:nvSpPr>
-          <p:cNvPr id="4" name="日期占位符 3">
-            <a:extLst>
-              <a:ext uri="{FF2B5EF4-FFF2-40B4-BE49-F238E27FC236}">
-                <a16:creationId xmlns:a16="http://schemas.microsoft.com/office/drawing/2014/main" id="{98911F68-DBB0-6A24-61CA-AE807F1CCFEB}"/>
-              </a:ext>
-            </a:extLst>
-          </p:cNvPr>
+            <a:endParaRPr lang="en-US" dirty="0"/>
+          </a:p>
+        </p:txBody>
+      </p:sp>
+      <p:sp>
+        <p:nvSpPr>
+          <p:cNvPr id="4" name="Date Placeholder 3"/>
           <p:cNvSpPr>
             <a:spLocks noGrp="1"/>
           </p:cNvSpPr>
@@ -452,7 +415,7 @@
           <a:p>
             <a:fld id="{16165D88-AD7F-4A3E-AF0D-D47865DDC7CF}" type="datetimeFigureOut">
               <a:rPr lang="zh-CN" altLang="en-US" smtClean="0"/>
-              <a:t>2026/5/8</a:t>
+              <a:t>2026/5/29</a:t>
             </a:fld>
             <a:endParaRPr lang="zh-CN" altLang="en-US"/>
           </a:p>
@@ -460,13 +423,7 @@
       </p:sp>
       <p:sp>
         <p:nvSpPr>
-          <p:cNvPr id="5" name="页脚占位符 4">
-            <a:extLst>
-              <a:ext uri="{FF2B5EF4-FFF2-40B4-BE49-F238E27FC236}">
-                <a16:creationId xmlns:a16="http://schemas.microsoft.com/office/drawing/2014/main" id="{CB827EC1-2AAA-CCD2-79C6-B397D78B46E9}"/>
-              </a:ext>
-            </a:extLst>
-          </p:cNvPr>
+          <p:cNvPr id="5" name="Footer Placeholder 4"/>
           <p:cNvSpPr>
             <a:spLocks noGrp="1"/>
           </p:cNvSpPr>
@@ -485,13 +442,7 @@
       </p:sp>
       <p:sp>
         <p:nvSpPr>
-          <p:cNvPr id="6" name="灯片编号占位符 5">
-            <a:extLst>
-              <a:ext uri="{FF2B5EF4-FFF2-40B4-BE49-F238E27FC236}">
-                <a16:creationId xmlns:a16="http://schemas.microsoft.com/office/drawing/2014/main" id="{6C1F3EF2-C122-DDEB-A04F-FB8279A0DAE3}"/>
-              </a:ext>
-            </a:extLst>
-          </p:cNvPr>
+          <p:cNvPr id="6" name="Slide Number Placeholder 5"/>
           <p:cNvSpPr>
             <a:spLocks noGrp="1"/>
           </p:cNvSpPr>
@@ -515,7 +466,7 @@
     </p:spTree>
     <p:extLst>
       <p:ext uri="{BB962C8B-B14F-4D97-AF65-F5344CB8AC3E}">
-        <p14:creationId xmlns:p14="http://schemas.microsoft.com/office/powerpoint/2010/main" val="2240346346"/>
+        <p14:creationId xmlns:p14="http://schemas.microsoft.com/office/powerpoint/2010/main" val="2284429193"/>
       </p:ext>
     </p:extLst>
   </p:cSld>
@@ -544,13 +495,7 @@
       </p:grpSpPr>
       <p:sp>
         <p:nvSpPr>
-          <p:cNvPr id="2" name="竖排标题 1">
-            <a:extLst>
-              <a:ext uri="{FF2B5EF4-FFF2-40B4-BE49-F238E27FC236}">
-                <a16:creationId xmlns:a16="http://schemas.microsoft.com/office/drawing/2014/main" id="{CD8512C9-BF53-249D-2189-9481F7EF2478}"/>
-              </a:ext>
-            </a:extLst>
-          </p:cNvPr>
+          <p:cNvPr id="2" name="Vertical Title 1"/>
           <p:cNvSpPr>
             <a:spLocks noGrp="1"/>
           </p:cNvSpPr>
@@ -572,18 +517,13 @@
               <a:rPr lang="zh-CN" altLang="en-US"/>
               <a:t>单击此处编辑母版标题样式</a:t>
             </a:r>
-          </a:p>
-        </p:txBody>
-      </p:sp>
-      <p:sp>
-        <p:nvSpPr>
-          <p:cNvPr id="3" name="竖排文字占位符 2">
-            <a:extLst>
-              <a:ext uri="{FF2B5EF4-FFF2-40B4-BE49-F238E27FC236}">
-                <a16:creationId xmlns:a16="http://schemas.microsoft.com/office/drawing/2014/main" id="{13FBADE1-88D6-562F-72AE-A534E9ED31FA}"/>
-              </a:ext>
-            </a:extLst>
-          </p:cNvPr>
+            <a:endParaRPr lang="en-US" dirty="0"/>
+          </a:p>
+        </p:txBody>
+      </p:sp>
+      <p:sp>
+        <p:nvSpPr>
+          <p:cNvPr id="3" name="Vertical Text Placeholder 2"/>
           <p:cNvSpPr>
             <a:spLocks noGrp="1"/>
           </p:cNvSpPr>
@@ -634,18 +574,13 @@
               <a:rPr lang="zh-CN" altLang="en-US"/>
               <a:t>五级</a:t>
             </a:r>
-          </a:p>
-        </p:txBody>
-      </p:sp>
-      <p:sp>
-        <p:nvSpPr>
-          <p:cNvPr id="4" name="日期占位符 3">
-            <a:extLst>
-              <a:ext uri="{FF2B5EF4-FFF2-40B4-BE49-F238E27FC236}">
-                <a16:creationId xmlns:a16="http://schemas.microsoft.com/office/drawing/2014/main" id="{76102C4A-5625-870E-5423-A0BBFF9C95D8}"/>
-              </a:ext>
-            </a:extLst>
-          </p:cNvPr>
+            <a:endParaRPr lang="en-US" dirty="0"/>
+          </a:p>
+        </p:txBody>
+      </p:sp>
+      <p:sp>
+        <p:nvSpPr>
+          <p:cNvPr id="4" name="Date Placeholder 3"/>
           <p:cNvSpPr>
             <a:spLocks noGrp="1"/>
           </p:cNvSpPr>
@@ -660,7 +595,7 @@
           <a:p>
             <a:fld id="{16165D88-AD7F-4A3E-AF0D-D47865DDC7CF}" type="datetimeFigureOut">
               <a:rPr lang="zh-CN" altLang="en-US" smtClean="0"/>
-              <a:t>2026/5/8</a:t>
+              <a:t>2026/5/29</a:t>
             </a:fld>
             <a:endParaRPr lang="zh-CN" altLang="en-US"/>
           </a:p>
@@ -668,13 +603,7 @@
       </p:sp>
       <p:sp>
         <p:nvSpPr>
-          <p:cNvPr id="5" name="页脚占位符 4">
-            <a:extLst>
-              <a:ext uri="{FF2B5EF4-FFF2-40B4-BE49-F238E27FC236}">
-                <a16:creationId xmlns:a16="http://schemas.microsoft.com/office/drawing/2014/main" id="{82CA3468-3773-6A46-96C3-7F1226E8DF94}"/>
-              </a:ext>
-            </a:extLst>
-          </p:cNvPr>
+          <p:cNvPr id="5" name="Footer Placeholder 4"/>
           <p:cNvSpPr>
             <a:spLocks noGrp="1"/>
           </p:cNvSpPr>
@@ -693,13 +622,7 @@
       </p:sp>
       <p:sp>
         <p:nvSpPr>
-          <p:cNvPr id="6" name="灯片编号占位符 5">
-            <a:extLst>
-              <a:ext uri="{FF2B5EF4-FFF2-40B4-BE49-F238E27FC236}">
-                <a16:creationId xmlns:a16="http://schemas.microsoft.com/office/drawing/2014/main" id="{8B3C6E7B-B1FD-F5BC-A4AB-11D0710A8120}"/>
-              </a:ext>
-            </a:extLst>
-          </p:cNvPr>
+          <p:cNvPr id="6" name="Slide Number Placeholder 5"/>
           <p:cNvSpPr>
             <a:spLocks noGrp="1"/>
           </p:cNvSpPr>
@@ -723,7 +646,7 @@
     </p:spTree>
     <p:extLst>
       <p:ext uri="{BB962C8B-B14F-4D97-AF65-F5344CB8AC3E}">
-        <p14:creationId xmlns:p14="http://schemas.microsoft.com/office/powerpoint/2010/main" val="3106378737"/>
+        <p14:creationId xmlns:p14="http://schemas.microsoft.com/office/powerpoint/2010/main" val="2794684873"/>
       </p:ext>
     </p:extLst>
   </p:cSld>
@@ -752,13 +675,7 @@
       </p:grpSpPr>
       <p:sp>
         <p:nvSpPr>
-          <p:cNvPr id="2" name="标题 1">
-            <a:extLst>
-              <a:ext uri="{FF2B5EF4-FFF2-40B4-BE49-F238E27FC236}">
-                <a16:creationId xmlns:a16="http://schemas.microsoft.com/office/drawing/2014/main" id="{11B5552A-4197-022C-5C7E-C8E75D2B1107}"/>
-              </a:ext>
-            </a:extLst>
-          </p:cNvPr>
+          <p:cNvPr id="2" name="Title 1"/>
           <p:cNvSpPr>
             <a:spLocks noGrp="1"/>
           </p:cNvSpPr>
@@ -775,18 +692,13 @@
               <a:rPr lang="zh-CN" altLang="en-US"/>
               <a:t>单击此处编辑母版标题样式</a:t>
             </a:r>
-          </a:p>
-        </p:txBody>
-      </p:sp>
-      <p:sp>
-        <p:nvSpPr>
-          <p:cNvPr id="3" name="内容占位符 2">
-            <a:extLst>
-              <a:ext uri="{FF2B5EF4-FFF2-40B4-BE49-F238E27FC236}">
-                <a16:creationId xmlns:a16="http://schemas.microsoft.com/office/drawing/2014/main" id="{9DCB44D5-C317-7E32-2AE4-D961D0F1F2FC}"/>
-              </a:ext>
-            </a:extLst>
-          </p:cNvPr>
+            <a:endParaRPr lang="en-US" dirty="0"/>
+          </a:p>
+        </p:txBody>
+      </p:sp>
+      <p:sp>
+        <p:nvSpPr>
+          <p:cNvPr id="3" name="Content Placeholder 2"/>
           <p:cNvSpPr>
             <a:spLocks noGrp="1"/>
           </p:cNvSpPr>
@@ -832,18 +744,13 @@
               <a:rPr lang="zh-CN" altLang="en-US"/>
               <a:t>五级</a:t>
             </a:r>
-          </a:p>
-        </p:txBody>
-      </p:sp>
-      <p:sp>
-        <p:nvSpPr>
-          <p:cNvPr id="4" name="日期占位符 3">
-            <a:extLst>
-              <a:ext uri="{FF2B5EF4-FFF2-40B4-BE49-F238E27FC236}">
-                <a16:creationId xmlns:a16="http://schemas.microsoft.com/office/drawing/2014/main" id="{C848641A-2F7C-DD16-BAA0-FEC76C6B1C5F}"/>
-              </a:ext>
-            </a:extLst>
-          </p:cNvPr>
+            <a:endParaRPr lang="en-US" dirty="0"/>
+          </a:p>
+        </p:txBody>
+      </p:sp>
+      <p:sp>
+        <p:nvSpPr>
+          <p:cNvPr id="4" name="Date Placeholder 3"/>
           <p:cNvSpPr>
             <a:spLocks noGrp="1"/>
           </p:cNvSpPr>
@@ -858,7 +765,7 @@
           <a:p>
             <a:fld id="{16165D88-AD7F-4A3E-AF0D-D47865DDC7CF}" type="datetimeFigureOut">
               <a:rPr lang="zh-CN" altLang="en-US" smtClean="0"/>
-              <a:t>2026/5/8</a:t>
+              <a:t>2026/5/29</a:t>
             </a:fld>
             <a:endParaRPr lang="zh-CN" altLang="en-US"/>
           </a:p>
@@ -866,13 +773,7 @@
       </p:sp>
       <p:sp>
         <p:nvSpPr>
-          <p:cNvPr id="5" name="页脚占位符 4">
-            <a:extLst>
-              <a:ext uri="{FF2B5EF4-FFF2-40B4-BE49-F238E27FC236}">
-                <a16:creationId xmlns:a16="http://schemas.microsoft.com/office/drawing/2014/main" id="{D4FF9A25-B838-D294-9CA8-1EB4B112B3D6}"/>
-              </a:ext>
-            </a:extLst>
-          </p:cNvPr>
+          <p:cNvPr id="5" name="Footer Placeholder 4"/>
           <p:cNvSpPr>
             <a:spLocks noGrp="1"/>
           </p:cNvSpPr>
@@ -891,13 +792,7 @@
       </p:sp>
       <p:sp>
         <p:nvSpPr>
-          <p:cNvPr id="6" name="灯片编号占位符 5">
-            <a:extLst>
-              <a:ext uri="{FF2B5EF4-FFF2-40B4-BE49-F238E27FC236}">
-                <a16:creationId xmlns:a16="http://schemas.microsoft.com/office/drawing/2014/main" id="{1C315147-34D8-960F-E178-F715879A32C6}"/>
-              </a:ext>
-            </a:extLst>
-          </p:cNvPr>
+          <p:cNvPr id="6" name="Slide Number Placeholder 5"/>
           <p:cNvSpPr>
             <a:spLocks noGrp="1"/>
           </p:cNvSpPr>
@@ -921,7 +816,7 @@
     </p:spTree>
     <p:extLst>
       <p:ext uri="{BB962C8B-B14F-4D97-AF65-F5344CB8AC3E}">
-        <p14:creationId xmlns:p14="http://schemas.microsoft.com/office/powerpoint/2010/main" val="3147664669"/>
+        <p14:creationId xmlns:p14="http://schemas.microsoft.com/office/powerpoint/2010/main" val="2900316071"/>
       </p:ext>
     </p:extLst>
   </p:cSld>
@@ -950,13 +845,7 @@
       </p:grpSpPr>
       <p:sp>
         <p:nvSpPr>
-          <p:cNvPr id="2" name="标题 1">
-            <a:extLst>
-              <a:ext uri="{FF2B5EF4-FFF2-40B4-BE49-F238E27FC236}">
-                <a16:creationId xmlns:a16="http://schemas.microsoft.com/office/drawing/2014/main" id="{8E862E9E-E1D6-1755-89CC-A3D43FFF2C66}"/>
-              </a:ext>
-            </a:extLst>
-          </p:cNvPr>
+          <p:cNvPr id="2" name="Title 1"/>
           <p:cNvSpPr>
             <a:spLocks noGrp="1"/>
           </p:cNvSpPr>
@@ -982,18 +871,13 @@
               <a:rPr lang="zh-CN" altLang="en-US"/>
               <a:t>单击此处编辑母版标题样式</a:t>
             </a:r>
-          </a:p>
-        </p:txBody>
-      </p:sp>
-      <p:sp>
-        <p:nvSpPr>
-          <p:cNvPr id="3" name="文本占位符 2">
-            <a:extLst>
-              <a:ext uri="{FF2B5EF4-FFF2-40B4-BE49-F238E27FC236}">
-                <a16:creationId xmlns:a16="http://schemas.microsoft.com/office/drawing/2014/main" id="{AE8DEF69-15D5-06C3-EB8E-B14FD8AA80AC}"/>
-              </a:ext>
-            </a:extLst>
-          </p:cNvPr>
+            <a:endParaRPr lang="en-US" dirty="0"/>
+          </a:p>
+        </p:txBody>
+      </p:sp>
+      <p:sp>
+        <p:nvSpPr>
+          <p:cNvPr id="3" name="Text Placeholder 2"/>
           <p:cNvSpPr>
             <a:spLocks noGrp="1"/>
           </p:cNvSpPr>
@@ -1015,7 +899,7 @@
               <a:defRPr sz="2400">
                 <a:solidFill>
                   <a:schemeClr val="tx1">
-                    <a:tint val="82000"/>
+                    <a:tint val="75000"/>
                   </a:schemeClr>
                 </a:solidFill>
               </a:defRPr>
@@ -1025,7 +909,7 @@
               <a:defRPr sz="2000">
                 <a:solidFill>
                   <a:schemeClr val="tx1">
-                    <a:tint val="82000"/>
+                    <a:tint val="75000"/>
                   </a:schemeClr>
                 </a:solidFill>
               </a:defRPr>
@@ -1035,7 +919,7 @@
               <a:defRPr sz="1800">
                 <a:solidFill>
                   <a:schemeClr val="tx1">
-                    <a:tint val="82000"/>
+                    <a:tint val="75000"/>
                   </a:schemeClr>
                 </a:solidFill>
               </a:defRPr>
@@ -1045,7 +929,7 @@
               <a:defRPr sz="1600">
                 <a:solidFill>
                   <a:schemeClr val="tx1">
-                    <a:tint val="82000"/>
+                    <a:tint val="75000"/>
                   </a:schemeClr>
                 </a:solidFill>
               </a:defRPr>
@@ -1055,7 +939,7 @@
               <a:defRPr sz="1600">
                 <a:solidFill>
                   <a:schemeClr val="tx1">
-                    <a:tint val="82000"/>
+                    <a:tint val="75000"/>
                   </a:schemeClr>
                 </a:solidFill>
               </a:defRPr>
@@ -1065,7 +949,7 @@
               <a:defRPr sz="1600">
                 <a:solidFill>
                   <a:schemeClr val="tx1">
-                    <a:tint val="82000"/>
+                    <a:tint val="75000"/>
                   </a:schemeClr>
                 </a:solidFill>
               </a:defRPr>
@@ -1075,7 +959,7 @@
               <a:defRPr sz="1600">
                 <a:solidFill>
                   <a:schemeClr val="tx1">
-                    <a:tint val="82000"/>
+                    <a:tint val="75000"/>
                   </a:schemeClr>
                 </a:solidFill>
               </a:defRPr>
@@ -1085,7 +969,7 @@
               <a:defRPr sz="1600">
                 <a:solidFill>
                   <a:schemeClr val="tx1">
-                    <a:tint val="82000"/>
+                    <a:tint val="75000"/>
                   </a:schemeClr>
                 </a:solidFill>
               </a:defRPr>
@@ -1095,7 +979,7 @@
               <a:defRPr sz="1600">
                 <a:solidFill>
                   <a:schemeClr val="tx1">
-                    <a:tint val="82000"/>
+                    <a:tint val="75000"/>
                   </a:schemeClr>
                 </a:solidFill>
               </a:defRPr>
@@ -1112,13 +996,7 @@
       </p:sp>
       <p:sp>
         <p:nvSpPr>
-          <p:cNvPr id="4" name="日期占位符 3">
-            <a:extLst>
-              <a:ext uri="{FF2B5EF4-FFF2-40B4-BE49-F238E27FC236}">
-                <a16:creationId xmlns:a16="http://schemas.microsoft.com/office/drawing/2014/main" id="{13A962D7-F174-606D-1458-15D0BAF1DC94}"/>
-              </a:ext>
-            </a:extLst>
-          </p:cNvPr>
+          <p:cNvPr id="4" name="Date Placeholder 3"/>
           <p:cNvSpPr>
             <a:spLocks noGrp="1"/>
           </p:cNvSpPr>
@@ -1133,7 +1011,7 @@
           <a:p>
             <a:fld id="{16165D88-AD7F-4A3E-AF0D-D47865DDC7CF}" type="datetimeFigureOut">
               <a:rPr lang="zh-CN" altLang="en-US" smtClean="0"/>
-              <a:t>2026/5/8</a:t>
+              <a:t>2026/5/29</a:t>
             </a:fld>
             <a:endParaRPr lang="zh-CN" altLang="en-US"/>
           </a:p>
@@ -1141,13 +1019,7 @@
       </p:sp>
       <p:sp>
         <p:nvSpPr>
-          <p:cNvPr id="5" name="页脚占位符 4">
-            <a:extLst>
-              <a:ext uri="{FF2B5EF4-FFF2-40B4-BE49-F238E27FC236}">
-                <a16:creationId xmlns:a16="http://schemas.microsoft.com/office/drawing/2014/main" id="{CE1F1B1B-0338-C912-53E7-227C2CE05BED}"/>
-              </a:ext>
-            </a:extLst>
-          </p:cNvPr>
+          <p:cNvPr id="5" name="Footer Placeholder 4"/>
           <p:cNvSpPr>
             <a:spLocks noGrp="1"/>
           </p:cNvSpPr>
@@ -1166,13 +1038,7 @@
       </p:sp>
       <p:sp>
         <p:nvSpPr>
-          <p:cNvPr id="6" name="灯片编号占位符 5">
-            <a:extLst>
-              <a:ext uri="{FF2B5EF4-FFF2-40B4-BE49-F238E27FC236}">
-                <a16:creationId xmlns:a16="http://schemas.microsoft.com/office/drawing/2014/main" id="{ED0B4F20-7386-EEB5-BD54-805EEB837238}"/>
-              </a:ext>
-            </a:extLst>
-          </p:cNvPr>
+          <p:cNvPr id="6" name="Slide Number Placeholder 5"/>
           <p:cNvSpPr>
             <a:spLocks noGrp="1"/>
           </p:cNvSpPr>
@@ -1196,7 +1062,7 @@
     </p:spTree>
     <p:extLst>
       <p:ext uri="{BB962C8B-B14F-4D97-AF65-F5344CB8AC3E}">
-        <p14:creationId xmlns:p14="http://schemas.microsoft.com/office/powerpoint/2010/main" val="3393095544"/>
+        <p14:creationId xmlns:p14="http://schemas.microsoft.com/office/powerpoint/2010/main" val="4030960876"/>
       </p:ext>
     </p:extLst>
   </p:cSld>
@@ -1225,13 +1091,7 @@
       </p:grpSpPr>
       <p:sp>
         <p:nvSpPr>
-          <p:cNvPr id="2" name="标题 1">
-            <a:extLst>
-              <a:ext uri="{FF2B5EF4-FFF2-40B4-BE49-F238E27FC236}">
-                <a16:creationId xmlns:a16="http://schemas.microsoft.com/office/drawing/2014/main" id="{D8E5F154-67AF-CE25-12EC-EE2C8E69CCF1}"/>
-              </a:ext>
-            </a:extLst>
-          </p:cNvPr>
+          <p:cNvPr id="2" name="Title 1"/>
           <p:cNvSpPr>
             <a:spLocks noGrp="1"/>
           </p:cNvSpPr>
@@ -1248,18 +1108,13 @@
               <a:rPr lang="zh-CN" altLang="en-US"/>
               <a:t>单击此处编辑母版标题样式</a:t>
             </a:r>
-          </a:p>
-        </p:txBody>
-      </p:sp>
-      <p:sp>
-        <p:nvSpPr>
-          <p:cNvPr id="3" name="内容占位符 2">
-            <a:extLst>
-              <a:ext uri="{FF2B5EF4-FFF2-40B4-BE49-F238E27FC236}">
-                <a16:creationId xmlns:a16="http://schemas.microsoft.com/office/drawing/2014/main" id="{0F2E7B59-4DF8-9AD1-3CAF-4FBB26FA628C}"/>
-              </a:ext>
-            </a:extLst>
-          </p:cNvPr>
+            <a:endParaRPr lang="en-US" dirty="0"/>
+          </a:p>
+        </p:txBody>
+      </p:sp>
+      <p:sp>
+        <p:nvSpPr>
+          <p:cNvPr id="3" name="Content Placeholder 2"/>
           <p:cNvSpPr>
             <a:spLocks noGrp="1"/>
           </p:cNvSpPr>
@@ -1310,18 +1165,13 @@
               <a:rPr lang="zh-CN" altLang="en-US"/>
               <a:t>五级</a:t>
             </a:r>
-          </a:p>
-        </p:txBody>
-      </p:sp>
-      <p:sp>
-        <p:nvSpPr>
-          <p:cNvPr id="4" name="内容占位符 3">
-            <a:extLst>
-              <a:ext uri="{FF2B5EF4-FFF2-40B4-BE49-F238E27FC236}">
-                <a16:creationId xmlns:a16="http://schemas.microsoft.com/office/drawing/2014/main" id="{357C3E42-9CEC-E64E-C3FD-4B906A4A14BE}"/>
-              </a:ext>
-            </a:extLst>
-          </p:cNvPr>
+            <a:endParaRPr lang="en-US" dirty="0"/>
+          </a:p>
+        </p:txBody>
+      </p:sp>
+      <p:sp>
+        <p:nvSpPr>
+          <p:cNvPr id="4" name="Content Placeholder 3"/>
           <p:cNvSpPr>
             <a:spLocks noGrp="1"/>
           </p:cNvSpPr>
@@ -1372,18 +1222,13 @@
               <a:rPr lang="zh-CN" altLang="en-US"/>
               <a:t>五级</a:t>
             </a:r>
-          </a:p>
-        </p:txBody>
-      </p:sp>
-      <p:sp>
-        <p:nvSpPr>
-          <p:cNvPr id="5" name="日期占位符 4">
-            <a:extLst>
-              <a:ext uri="{FF2B5EF4-FFF2-40B4-BE49-F238E27FC236}">
-                <a16:creationId xmlns:a16="http://schemas.microsoft.com/office/drawing/2014/main" id="{87FB1418-77C2-2856-1BA5-F45F8154967D}"/>
-              </a:ext>
-            </a:extLst>
-          </p:cNvPr>
+            <a:endParaRPr lang="en-US" dirty="0"/>
+          </a:p>
+        </p:txBody>
+      </p:sp>
+      <p:sp>
+        <p:nvSpPr>
+          <p:cNvPr id="5" name="Date Placeholder 4"/>
           <p:cNvSpPr>
             <a:spLocks noGrp="1"/>
           </p:cNvSpPr>
@@ -1398,7 +1243,7 @@
           <a:p>
             <a:fld id="{16165D88-AD7F-4A3E-AF0D-D47865DDC7CF}" type="datetimeFigureOut">
               <a:rPr lang="zh-CN" altLang="en-US" smtClean="0"/>
-              <a:t>2026/5/8</a:t>
+              <a:t>2026/5/29</a:t>
             </a:fld>
             <a:endParaRPr lang="zh-CN" altLang="en-US"/>
           </a:p>
@@ -1406,13 +1251,7 @@
       </p:sp>
       <p:sp>
         <p:nvSpPr>
-          <p:cNvPr id="6" name="页脚占位符 5">
-            <a:extLst>
-              <a:ext uri="{FF2B5EF4-FFF2-40B4-BE49-F238E27FC236}">
-                <a16:creationId xmlns:a16="http://schemas.microsoft.com/office/drawing/2014/main" id="{18FB7029-D51F-EECE-A3CE-34830A812555}"/>
-              </a:ext>
-            </a:extLst>
-          </p:cNvPr>
+          <p:cNvPr id="6" name="Footer Placeholder 5"/>
           <p:cNvSpPr>
             <a:spLocks noGrp="1"/>
           </p:cNvSpPr>
@@ -1431,13 +1270,7 @@
       </p:sp>
       <p:sp>
         <p:nvSpPr>
-          <p:cNvPr id="7" name="灯片编号占位符 6">
-            <a:extLst>
-              <a:ext uri="{FF2B5EF4-FFF2-40B4-BE49-F238E27FC236}">
-                <a16:creationId xmlns:a16="http://schemas.microsoft.com/office/drawing/2014/main" id="{65841B56-27AC-7742-8CCE-2EB6273C5A1E}"/>
-              </a:ext>
-            </a:extLst>
-          </p:cNvPr>
+          <p:cNvPr id="7" name="Slide Number Placeholder 6"/>
           <p:cNvSpPr>
             <a:spLocks noGrp="1"/>
           </p:cNvSpPr>
@@ -1461,7 +1294,7 @@
     </p:spTree>
     <p:extLst>
       <p:ext uri="{BB962C8B-B14F-4D97-AF65-F5344CB8AC3E}">
-        <p14:creationId xmlns:p14="http://schemas.microsoft.com/office/powerpoint/2010/main" val="2688373729"/>
+        <p14:creationId xmlns:p14="http://schemas.microsoft.com/office/powerpoint/2010/main" val="2367383013"/>
       </p:ext>
     </p:extLst>
   </p:cSld>
@@ -1490,13 +1323,7 @@
       </p:grpSpPr>
       <p:sp>
         <p:nvSpPr>
-          <p:cNvPr id="2" name="标题 1">
-            <a:extLst>
-              <a:ext uri="{FF2B5EF4-FFF2-40B4-BE49-F238E27FC236}">
-                <a16:creationId xmlns:a16="http://schemas.microsoft.com/office/drawing/2014/main" id="{D3FD4870-7CD6-246B-971C-6DCCF397AEAA}"/>
-              </a:ext>
-            </a:extLst>
-          </p:cNvPr>
+          <p:cNvPr id="2" name="Title 1"/>
           <p:cNvSpPr>
             <a:spLocks noGrp="1"/>
           </p:cNvSpPr>
@@ -1518,18 +1345,13 @@
               <a:rPr lang="zh-CN" altLang="en-US"/>
               <a:t>单击此处编辑母版标题样式</a:t>
             </a:r>
-          </a:p>
-        </p:txBody>
-      </p:sp>
-      <p:sp>
-        <p:nvSpPr>
-          <p:cNvPr id="3" name="文本占位符 2">
-            <a:extLst>
-              <a:ext uri="{FF2B5EF4-FFF2-40B4-BE49-F238E27FC236}">
-                <a16:creationId xmlns:a16="http://schemas.microsoft.com/office/drawing/2014/main" id="{CA393760-3BD4-88DF-7343-97FF40779779}"/>
-              </a:ext>
-            </a:extLst>
-          </p:cNvPr>
+            <a:endParaRPr lang="en-US" dirty="0"/>
+          </a:p>
+        </p:txBody>
+      </p:sp>
+      <p:sp>
+        <p:nvSpPr>
+          <p:cNvPr id="3" name="Text Placeholder 2"/>
           <p:cNvSpPr>
             <a:spLocks noGrp="1"/>
           </p:cNvSpPr>
@@ -1594,13 +1416,7 @@
       </p:sp>
       <p:sp>
         <p:nvSpPr>
-          <p:cNvPr id="4" name="内容占位符 3">
-            <a:extLst>
-              <a:ext uri="{FF2B5EF4-FFF2-40B4-BE49-F238E27FC236}">
-                <a16:creationId xmlns:a16="http://schemas.microsoft.com/office/drawing/2014/main" id="{31853A46-8756-7236-8536-20AB19E77A47}"/>
-              </a:ext>
-            </a:extLst>
-          </p:cNvPr>
+          <p:cNvPr id="4" name="Content Placeholder 3"/>
           <p:cNvSpPr>
             <a:spLocks noGrp="1"/>
           </p:cNvSpPr>
@@ -1651,18 +1467,13 @@
               <a:rPr lang="zh-CN" altLang="en-US"/>
               <a:t>五级</a:t>
             </a:r>
-          </a:p>
-        </p:txBody>
-      </p:sp>
-      <p:sp>
-        <p:nvSpPr>
-          <p:cNvPr id="5" name="文本占位符 4">
-            <a:extLst>
-              <a:ext uri="{FF2B5EF4-FFF2-40B4-BE49-F238E27FC236}">
-                <a16:creationId xmlns:a16="http://schemas.microsoft.com/office/drawing/2014/main" id="{B2647B2F-9609-0E33-E64D-187D59993845}"/>
-              </a:ext>
-            </a:extLst>
-          </p:cNvPr>
+            <a:endParaRPr lang="en-US" dirty="0"/>
+          </a:p>
+        </p:txBody>
+      </p:sp>
+      <p:sp>
+        <p:nvSpPr>
+          <p:cNvPr id="5" name="Text Placeholder 4"/>
           <p:cNvSpPr>
             <a:spLocks noGrp="1"/>
           </p:cNvSpPr>
@@ -1727,13 +1538,7 @@
       </p:sp>
       <p:sp>
         <p:nvSpPr>
-          <p:cNvPr id="6" name="内容占位符 5">
-            <a:extLst>
-              <a:ext uri="{FF2B5EF4-FFF2-40B4-BE49-F238E27FC236}">
-                <a16:creationId xmlns:a16="http://schemas.microsoft.com/office/drawing/2014/main" id="{813CE0D6-AC3B-16B1-61A4-3F34E9A54D19}"/>
-              </a:ext>
-            </a:extLst>
-          </p:cNvPr>
+          <p:cNvPr id="6" name="Content Placeholder 5"/>
           <p:cNvSpPr>
             <a:spLocks noGrp="1"/>
           </p:cNvSpPr>
@@ -1784,18 +1589,13 @@
               <a:rPr lang="zh-CN" altLang="en-US"/>
               <a:t>五级</a:t>
             </a:r>
-          </a:p>
-        </p:txBody>
-      </p:sp>
-      <p:sp>
-        <p:nvSpPr>
-          <p:cNvPr id="7" name="日期占位符 6">
-            <a:extLst>
-              <a:ext uri="{FF2B5EF4-FFF2-40B4-BE49-F238E27FC236}">
-                <a16:creationId xmlns:a16="http://schemas.microsoft.com/office/drawing/2014/main" id="{DBE5392D-157E-7FE0-ABFF-9CD86C83FE34}"/>
-              </a:ext>
-            </a:extLst>
-          </p:cNvPr>
+            <a:endParaRPr lang="en-US" dirty="0"/>
+          </a:p>
+        </p:txBody>
+      </p:sp>
+      <p:sp>
+        <p:nvSpPr>
+          <p:cNvPr id="7" name="Date Placeholder 6"/>
           <p:cNvSpPr>
             <a:spLocks noGrp="1"/>
           </p:cNvSpPr>
@@ -1810,7 +1610,7 @@
           <a:p>
             <a:fld id="{16165D88-AD7F-4A3E-AF0D-D47865DDC7CF}" type="datetimeFigureOut">
               <a:rPr lang="zh-CN" altLang="en-US" smtClean="0"/>
-              <a:t>2026/5/8</a:t>
+              <a:t>2026/5/29</a:t>
             </a:fld>
             <a:endParaRPr lang="zh-CN" altLang="en-US"/>
           </a:p>
@@ -1818,13 +1618,7 @@
       </p:sp>
       <p:sp>
         <p:nvSpPr>
-          <p:cNvPr id="8" name="页脚占位符 7">
-            <a:extLst>
-              <a:ext uri="{FF2B5EF4-FFF2-40B4-BE49-F238E27FC236}">
-                <a16:creationId xmlns:a16="http://schemas.microsoft.com/office/drawing/2014/main" id="{BCDB70DD-AA85-F618-A740-ECEA2D7C92CE}"/>
-              </a:ext>
-            </a:extLst>
-          </p:cNvPr>
+          <p:cNvPr id="8" name="Footer Placeholder 7"/>
           <p:cNvSpPr>
             <a:spLocks noGrp="1"/>
           </p:cNvSpPr>
@@ -1843,13 +1637,7 @@
       </p:sp>
       <p:sp>
         <p:nvSpPr>
-          <p:cNvPr id="9" name="灯片编号占位符 8">
-            <a:extLst>
-              <a:ext uri="{FF2B5EF4-FFF2-40B4-BE49-F238E27FC236}">
-                <a16:creationId xmlns:a16="http://schemas.microsoft.com/office/drawing/2014/main" id="{FCA8D2A3-6A68-59EB-AAA6-2C891C215B9C}"/>
-              </a:ext>
-            </a:extLst>
-          </p:cNvPr>
+          <p:cNvPr id="9" name="Slide Number Placeholder 8"/>
           <p:cNvSpPr>
             <a:spLocks noGrp="1"/>
           </p:cNvSpPr>
@@ -1873,7 +1661,7 @@
     </p:spTree>
     <p:extLst>
       <p:ext uri="{BB962C8B-B14F-4D97-AF65-F5344CB8AC3E}">
-        <p14:creationId xmlns:p14="http://schemas.microsoft.com/office/powerpoint/2010/main" val="3612889251"/>
+        <p14:creationId xmlns:p14="http://schemas.microsoft.com/office/powerpoint/2010/main" val="3733157044"/>
       </p:ext>
     </p:extLst>
   </p:cSld>
@@ -1902,13 +1690,7 @@
       </p:grpSpPr>
       <p:sp>
         <p:nvSpPr>
-          <p:cNvPr id="2" name="标题 1">
-            <a:extLst>
-              <a:ext uri="{FF2B5EF4-FFF2-40B4-BE49-F238E27FC236}">
-                <a16:creationId xmlns:a16="http://schemas.microsoft.com/office/drawing/2014/main" id="{67BA0BF6-E440-A5DC-0CEC-2D1166C0F85D}"/>
-              </a:ext>
-            </a:extLst>
-          </p:cNvPr>
+          <p:cNvPr id="2" name="Title 1"/>
           <p:cNvSpPr>
             <a:spLocks noGrp="1"/>
           </p:cNvSpPr>
@@ -1925,18 +1707,13 @@
               <a:rPr lang="zh-CN" altLang="en-US"/>
               <a:t>单击此处编辑母版标题样式</a:t>
             </a:r>
-          </a:p>
-        </p:txBody>
-      </p:sp>
-      <p:sp>
-        <p:nvSpPr>
-          <p:cNvPr id="3" name="日期占位符 2">
-            <a:extLst>
-              <a:ext uri="{FF2B5EF4-FFF2-40B4-BE49-F238E27FC236}">
-                <a16:creationId xmlns:a16="http://schemas.microsoft.com/office/drawing/2014/main" id="{B9DBD356-B843-5EF6-031C-E2D38747BB40}"/>
-              </a:ext>
-            </a:extLst>
-          </p:cNvPr>
+            <a:endParaRPr lang="en-US" dirty="0"/>
+          </a:p>
+        </p:txBody>
+      </p:sp>
+      <p:sp>
+        <p:nvSpPr>
+          <p:cNvPr id="3" name="Date Placeholder 2"/>
           <p:cNvSpPr>
             <a:spLocks noGrp="1"/>
           </p:cNvSpPr>
@@ -1951,7 +1728,7 @@
           <a:p>
             <a:fld id="{16165D88-AD7F-4A3E-AF0D-D47865DDC7CF}" type="datetimeFigureOut">
               <a:rPr lang="zh-CN" altLang="en-US" smtClean="0"/>
-              <a:t>2026/5/8</a:t>
+              <a:t>2026/5/29</a:t>
             </a:fld>
             <a:endParaRPr lang="zh-CN" altLang="en-US"/>
           </a:p>
@@ -1959,13 +1736,7 @@
       </p:sp>
       <p:sp>
         <p:nvSpPr>
-          <p:cNvPr id="4" name="页脚占位符 3">
-            <a:extLst>
-              <a:ext uri="{FF2B5EF4-FFF2-40B4-BE49-F238E27FC236}">
-                <a16:creationId xmlns:a16="http://schemas.microsoft.com/office/drawing/2014/main" id="{90D1C850-5E5E-0450-5E9D-CC565A17BB3B}"/>
-              </a:ext>
-            </a:extLst>
-          </p:cNvPr>
+          <p:cNvPr id="4" name="Footer Placeholder 3"/>
           <p:cNvSpPr>
             <a:spLocks noGrp="1"/>
           </p:cNvSpPr>
@@ -1984,13 +1755,7 @@
       </p:sp>
       <p:sp>
         <p:nvSpPr>
-          <p:cNvPr id="5" name="灯片编号占位符 4">
-            <a:extLst>
-              <a:ext uri="{FF2B5EF4-FFF2-40B4-BE49-F238E27FC236}">
-                <a16:creationId xmlns:a16="http://schemas.microsoft.com/office/drawing/2014/main" id="{978BCCFC-8A6E-9CDF-AC37-CAD6D7B93029}"/>
-              </a:ext>
-            </a:extLst>
-          </p:cNvPr>
+          <p:cNvPr id="5" name="Slide Number Placeholder 4"/>
           <p:cNvSpPr>
             <a:spLocks noGrp="1"/>
           </p:cNvSpPr>
@@ -2014,7 +1779,7 @@
     </p:spTree>
     <p:extLst>
       <p:ext uri="{BB962C8B-B14F-4D97-AF65-F5344CB8AC3E}">
-        <p14:creationId xmlns:p14="http://schemas.microsoft.com/office/powerpoint/2010/main" val="1205221228"/>
+        <p14:creationId xmlns:p14="http://schemas.microsoft.com/office/powerpoint/2010/main" val="1838596636"/>
       </p:ext>
     </p:extLst>
   </p:cSld>
@@ -2043,13 +1808,7 @@
       </p:grpSpPr>
       <p:sp>
         <p:nvSpPr>
-          <p:cNvPr id="2" name="日期占位符 1">
-            <a:extLst>
-              <a:ext uri="{FF2B5EF4-FFF2-40B4-BE49-F238E27FC236}">
-                <a16:creationId xmlns:a16="http://schemas.microsoft.com/office/drawing/2014/main" id="{537413EC-73FD-71B9-E3F0-0C7E5B63E20B}"/>
-              </a:ext>
-            </a:extLst>
-          </p:cNvPr>
+          <p:cNvPr id="2" name="Date Placeholder 1"/>
           <p:cNvSpPr>
             <a:spLocks noGrp="1"/>
           </p:cNvSpPr>
@@ -2064,7 +1823,7 @@
           <a:p>
             <a:fld id="{16165D88-AD7F-4A3E-AF0D-D47865DDC7CF}" type="datetimeFigureOut">
               <a:rPr lang="zh-CN" altLang="en-US" smtClean="0"/>
-              <a:t>2026/5/8</a:t>
+              <a:t>2026/5/29</a:t>
             </a:fld>
             <a:endParaRPr lang="zh-CN" altLang="en-US"/>
           </a:p>
@@ -2072,13 +1831,7 @@
       </p:sp>
       <p:sp>
         <p:nvSpPr>
-          <p:cNvPr id="3" name="页脚占位符 2">
-            <a:extLst>
-              <a:ext uri="{FF2B5EF4-FFF2-40B4-BE49-F238E27FC236}">
-                <a16:creationId xmlns:a16="http://schemas.microsoft.com/office/drawing/2014/main" id="{1416E62D-79EB-306D-6C26-B5749E59254D}"/>
-              </a:ext>
-            </a:extLst>
-          </p:cNvPr>
+          <p:cNvPr id="3" name="Footer Placeholder 2"/>
           <p:cNvSpPr>
             <a:spLocks noGrp="1"/>
           </p:cNvSpPr>
@@ -2097,13 +1850,7 @@
       </p:sp>
       <p:sp>
         <p:nvSpPr>
-          <p:cNvPr id="4" name="灯片编号占位符 3">
-            <a:extLst>
-              <a:ext uri="{FF2B5EF4-FFF2-40B4-BE49-F238E27FC236}">
-                <a16:creationId xmlns:a16="http://schemas.microsoft.com/office/drawing/2014/main" id="{732EB2B2-1117-2A42-73B8-545611BD2461}"/>
-              </a:ext>
-            </a:extLst>
-          </p:cNvPr>
+          <p:cNvPr id="4" name="Slide Number Placeholder 3"/>
           <p:cNvSpPr>
             <a:spLocks noGrp="1"/>
           </p:cNvSpPr>
@@ -2127,7 +1874,7 @@
     </p:spTree>
     <p:extLst>
       <p:ext uri="{BB962C8B-B14F-4D97-AF65-F5344CB8AC3E}">
-        <p14:creationId xmlns:p14="http://schemas.microsoft.com/office/powerpoint/2010/main" val="2313660768"/>
+        <p14:creationId xmlns:p14="http://schemas.microsoft.com/office/powerpoint/2010/main" val="2343779416"/>
       </p:ext>
     </p:extLst>
   </p:cSld>
@@ -2156,13 +1903,7 @@
       </p:grpSpPr>
       <p:sp>
         <p:nvSpPr>
-          <p:cNvPr id="2" name="标题 1">
-            <a:extLst>
-              <a:ext uri="{FF2B5EF4-FFF2-40B4-BE49-F238E27FC236}">
-                <a16:creationId xmlns:a16="http://schemas.microsoft.com/office/drawing/2014/main" id="{8148D4A1-03E7-D0EE-6FE2-875A9FF12C06}"/>
-              </a:ext>
-            </a:extLst>
-          </p:cNvPr>
+          <p:cNvPr id="2" name="Title 1"/>
           <p:cNvSpPr>
             <a:spLocks noGrp="1"/>
           </p:cNvSpPr>
@@ -2188,18 +1929,13 @@
               <a:rPr lang="zh-CN" altLang="en-US"/>
               <a:t>单击此处编辑母版标题样式</a:t>
             </a:r>
-          </a:p>
-        </p:txBody>
-      </p:sp>
-      <p:sp>
-        <p:nvSpPr>
-          <p:cNvPr id="3" name="内容占位符 2">
-            <a:extLst>
-              <a:ext uri="{FF2B5EF4-FFF2-40B4-BE49-F238E27FC236}">
-                <a16:creationId xmlns:a16="http://schemas.microsoft.com/office/drawing/2014/main" id="{687279BE-499F-DFD8-D170-5E6E5EF1DCEE}"/>
-              </a:ext>
-            </a:extLst>
-          </p:cNvPr>
+            <a:endParaRPr lang="en-US" dirty="0"/>
+          </a:p>
+        </p:txBody>
+      </p:sp>
+      <p:sp>
+        <p:nvSpPr>
+          <p:cNvPr id="3" name="Content Placeholder 2"/>
           <p:cNvSpPr>
             <a:spLocks noGrp="1"/>
           </p:cNvSpPr>
@@ -2278,18 +2014,13 @@
               <a:rPr lang="zh-CN" altLang="en-US"/>
               <a:t>五级</a:t>
             </a:r>
-          </a:p>
-        </p:txBody>
-      </p:sp>
-      <p:sp>
-        <p:nvSpPr>
-          <p:cNvPr id="4" name="文本占位符 3">
-            <a:extLst>
-              <a:ext uri="{FF2B5EF4-FFF2-40B4-BE49-F238E27FC236}">
-                <a16:creationId xmlns:a16="http://schemas.microsoft.com/office/drawing/2014/main" id="{36D6E191-4F22-D980-95A6-D8F628F056F5}"/>
-              </a:ext>
-            </a:extLst>
-          </p:cNvPr>
+            <a:endParaRPr lang="en-US" dirty="0"/>
+          </a:p>
+        </p:txBody>
+      </p:sp>
+      <p:sp>
+        <p:nvSpPr>
+          <p:cNvPr id="4" name="Text Placeholder 3"/>
           <p:cNvSpPr>
             <a:spLocks noGrp="1"/>
           </p:cNvSpPr>
@@ -2354,13 +2085,7 @@
       </p:sp>
       <p:sp>
         <p:nvSpPr>
-          <p:cNvPr id="5" name="日期占位符 4">
-            <a:extLst>
-              <a:ext uri="{FF2B5EF4-FFF2-40B4-BE49-F238E27FC236}">
-                <a16:creationId xmlns:a16="http://schemas.microsoft.com/office/drawing/2014/main" id="{4C595A9E-F119-4335-044A-616B24E6A325}"/>
-              </a:ext>
-            </a:extLst>
-          </p:cNvPr>
+          <p:cNvPr id="5" name="Date Placeholder 4"/>
           <p:cNvSpPr>
             <a:spLocks noGrp="1"/>
           </p:cNvSpPr>
@@ -2375,7 +2100,7 @@
           <a:p>
             <a:fld id="{16165D88-AD7F-4A3E-AF0D-D47865DDC7CF}" type="datetimeFigureOut">
               <a:rPr lang="zh-CN" altLang="en-US" smtClean="0"/>
-              <a:t>2026/5/8</a:t>
+              <a:t>2026/5/29</a:t>
             </a:fld>
             <a:endParaRPr lang="zh-CN" altLang="en-US"/>
           </a:p>
@@ -2383,13 +2108,7 @@
       </p:sp>
       <p:sp>
         <p:nvSpPr>
-          <p:cNvPr id="6" name="页脚占位符 5">
-            <a:extLst>
-              <a:ext uri="{FF2B5EF4-FFF2-40B4-BE49-F238E27FC236}">
-                <a16:creationId xmlns:a16="http://schemas.microsoft.com/office/drawing/2014/main" id="{F5CE56EB-4F47-976B-B830-6F56B4795B2D}"/>
-              </a:ext>
-            </a:extLst>
-          </p:cNvPr>
+          <p:cNvPr id="6" name="Footer Placeholder 5"/>
           <p:cNvSpPr>
             <a:spLocks noGrp="1"/>
           </p:cNvSpPr>
@@ -2408,13 +2127,7 @@
       </p:sp>
       <p:sp>
         <p:nvSpPr>
-          <p:cNvPr id="7" name="灯片编号占位符 6">
-            <a:extLst>
-              <a:ext uri="{FF2B5EF4-FFF2-40B4-BE49-F238E27FC236}">
-                <a16:creationId xmlns:a16="http://schemas.microsoft.com/office/drawing/2014/main" id="{A3AD2971-A548-E873-5ABB-8B7CC9EF0EB5}"/>
-              </a:ext>
-            </a:extLst>
-          </p:cNvPr>
+          <p:cNvPr id="7" name="Slide Number Placeholder 6"/>
           <p:cNvSpPr>
             <a:spLocks noGrp="1"/>
           </p:cNvSpPr>
@@ -2438,7 +2151,7 @@
     </p:spTree>
     <p:extLst>
       <p:ext uri="{BB962C8B-B14F-4D97-AF65-F5344CB8AC3E}">
-        <p14:creationId xmlns:p14="http://schemas.microsoft.com/office/powerpoint/2010/main" val="2562410860"/>
+        <p14:creationId xmlns:p14="http://schemas.microsoft.com/office/powerpoint/2010/main" val="1933974110"/>
       </p:ext>
     </p:extLst>
   </p:cSld>
@@ -2467,13 +2180,7 @@
       </p:grpSpPr>
       <p:sp>
         <p:nvSpPr>
-          <p:cNvPr id="2" name="标题 1">
-            <a:extLst>
-              <a:ext uri="{FF2B5EF4-FFF2-40B4-BE49-F238E27FC236}">
-                <a16:creationId xmlns:a16="http://schemas.microsoft.com/office/drawing/2014/main" id="{40E9F10E-DDEC-9D0F-2368-8A6207B76FD6}"/>
-              </a:ext>
-            </a:extLst>
-          </p:cNvPr>
+          <p:cNvPr id="2" name="Title 1"/>
           <p:cNvSpPr>
             <a:spLocks noGrp="1"/>
           </p:cNvSpPr>
@@ -2499,20 +2206,15 @@
               <a:rPr lang="zh-CN" altLang="en-US"/>
               <a:t>单击此处编辑母版标题样式</a:t>
             </a:r>
-          </a:p>
-        </p:txBody>
-      </p:sp>
-      <p:sp>
-        <p:nvSpPr>
-          <p:cNvPr id="3" name="图片占位符 2">
-            <a:extLst>
-              <a:ext uri="{FF2B5EF4-FFF2-40B4-BE49-F238E27FC236}">
-                <a16:creationId xmlns:a16="http://schemas.microsoft.com/office/drawing/2014/main" id="{7E97C25B-EA7B-C126-2632-4F40F7F99216}"/>
-              </a:ext>
-            </a:extLst>
-          </p:cNvPr>
-          <p:cNvSpPr>
-            <a:spLocks noGrp="1"/>
+            <a:endParaRPr lang="en-US" dirty="0"/>
+          </a:p>
+        </p:txBody>
+      </p:sp>
+      <p:sp>
+        <p:nvSpPr>
+          <p:cNvPr id="3" name="Picture Placeholder 2"/>
+          <p:cNvSpPr>
+            <a:spLocks noGrp="1" noChangeAspect="1"/>
           </p:cNvSpPr>
           <p:nvPr>
             <p:ph type="pic" idx="1"/>
@@ -2525,7 +2227,7 @@
           </a:xfrm>
         </p:spPr>
         <p:txBody>
-          <a:bodyPr/>
+          <a:bodyPr anchor="t"/>
           <a:lstStyle>
             <a:lvl1pPr marL="0" indent="0">
               <a:buNone/>
@@ -2565,19 +2267,17 @@
             </a:lvl9pPr>
           </a:lstStyle>
           <a:p>
-            <a:endParaRPr lang="zh-CN" altLang="en-US"/>
-          </a:p>
-        </p:txBody>
-      </p:sp>
-      <p:sp>
-        <p:nvSpPr>
-          <p:cNvPr id="4" name="文本占位符 3">
-            <a:extLst>
-              <a:ext uri="{FF2B5EF4-FFF2-40B4-BE49-F238E27FC236}">
-                <a16:creationId xmlns:a16="http://schemas.microsoft.com/office/drawing/2014/main" id="{03CBEA10-5307-699A-3778-826065433C6D}"/>
-              </a:ext>
-            </a:extLst>
-          </p:cNvPr>
+            <a:r>
+              <a:rPr lang="zh-CN" altLang="en-US"/>
+              <a:t>单击图标添加图片</a:t>
+            </a:r>
+            <a:endParaRPr lang="en-US" dirty="0"/>
+          </a:p>
+        </p:txBody>
+      </p:sp>
+      <p:sp>
+        <p:nvSpPr>
+          <p:cNvPr id="4" name="Text Placeholder 3"/>
           <p:cNvSpPr>
             <a:spLocks noGrp="1"/>
           </p:cNvSpPr>
@@ -2642,13 +2342,7 @@
       </p:sp>
       <p:sp>
         <p:nvSpPr>
-          <p:cNvPr id="5" name="日期占位符 4">
-            <a:extLst>
-              <a:ext uri="{FF2B5EF4-FFF2-40B4-BE49-F238E27FC236}">
-                <a16:creationId xmlns:a16="http://schemas.microsoft.com/office/drawing/2014/main" id="{B81E4CF3-CCE7-2486-FAF7-7D8196C519AB}"/>
-              </a:ext>
-            </a:extLst>
-          </p:cNvPr>
+          <p:cNvPr id="5" name="Date Placeholder 4"/>
           <p:cNvSpPr>
             <a:spLocks noGrp="1"/>
           </p:cNvSpPr>
@@ -2663,7 +2357,7 @@
           <a:p>
             <a:fld id="{16165D88-AD7F-4A3E-AF0D-D47865DDC7CF}" type="datetimeFigureOut">
               <a:rPr lang="zh-CN" altLang="en-US" smtClean="0"/>
-              <a:t>2026/5/8</a:t>
+              <a:t>2026/5/29</a:t>
             </a:fld>
             <a:endParaRPr lang="zh-CN" altLang="en-US"/>
           </a:p>
@@ -2671,13 +2365,7 @@
       </p:sp>
       <p:sp>
         <p:nvSpPr>
-          <p:cNvPr id="6" name="页脚占位符 5">
-            <a:extLst>
-              <a:ext uri="{FF2B5EF4-FFF2-40B4-BE49-F238E27FC236}">
-                <a16:creationId xmlns:a16="http://schemas.microsoft.com/office/drawing/2014/main" id="{F27564AB-44F2-1031-4A38-569F019586E5}"/>
-              </a:ext>
-            </a:extLst>
-          </p:cNvPr>
+          <p:cNvPr id="6" name="Footer Placeholder 5"/>
           <p:cNvSpPr>
             <a:spLocks noGrp="1"/>
           </p:cNvSpPr>
@@ -2696,13 +2384,7 @@
       </p:sp>
       <p:sp>
         <p:nvSpPr>
-          <p:cNvPr id="7" name="灯片编号占位符 6">
-            <a:extLst>
-              <a:ext uri="{FF2B5EF4-FFF2-40B4-BE49-F238E27FC236}">
-                <a16:creationId xmlns:a16="http://schemas.microsoft.com/office/drawing/2014/main" id="{1B394A15-CF74-4559-D4AE-CA7B5AE2BCD8}"/>
-              </a:ext>
-            </a:extLst>
-          </p:cNvPr>
+          <p:cNvPr id="7" name="Slide Number Placeholder 6"/>
           <p:cNvSpPr>
             <a:spLocks noGrp="1"/>
           </p:cNvSpPr>
@@ -2726,7 +2408,7 @@
     </p:spTree>
     <p:extLst>
       <p:ext uri="{BB962C8B-B14F-4D97-AF65-F5344CB8AC3E}">
-        <p14:creationId xmlns:p14="http://schemas.microsoft.com/office/powerpoint/2010/main" val="2467382824"/>
+        <p14:creationId xmlns:p14="http://schemas.microsoft.com/office/powerpoint/2010/main" val="4009630458"/>
       </p:ext>
     </p:extLst>
   </p:cSld>
@@ -2760,13 +2442,7 @@
       </p:grpSpPr>
       <p:sp>
         <p:nvSpPr>
-          <p:cNvPr id="2" name="标题占位符 1">
-            <a:extLst>
-              <a:ext uri="{FF2B5EF4-FFF2-40B4-BE49-F238E27FC236}">
-                <a16:creationId xmlns:a16="http://schemas.microsoft.com/office/drawing/2014/main" id="{2A80C055-0790-393F-2272-9F5F340A9BF9}"/>
-              </a:ext>
-            </a:extLst>
-          </p:cNvPr>
+          <p:cNvPr id="2" name="Title Placeholder 1"/>
           <p:cNvSpPr>
             <a:spLocks noGrp="1"/>
           </p:cNvSpPr>
@@ -2793,18 +2469,13 @@
               <a:rPr lang="zh-CN" altLang="en-US"/>
               <a:t>单击此处编辑母版标题样式</a:t>
             </a:r>
-          </a:p>
-        </p:txBody>
-      </p:sp>
-      <p:sp>
-        <p:nvSpPr>
-          <p:cNvPr id="3" name="文本占位符 2">
-            <a:extLst>
-              <a:ext uri="{FF2B5EF4-FFF2-40B4-BE49-F238E27FC236}">
-                <a16:creationId xmlns:a16="http://schemas.microsoft.com/office/drawing/2014/main" id="{CD8CE3DC-DF50-AAF1-61A0-91DE0EA9A06B}"/>
-              </a:ext>
-            </a:extLst>
-          </p:cNvPr>
+            <a:endParaRPr lang="en-US" dirty="0"/>
+          </a:p>
+        </p:txBody>
+      </p:sp>
+      <p:sp>
+        <p:nvSpPr>
+          <p:cNvPr id="3" name="Text Placeholder 2"/>
           <p:cNvSpPr>
             <a:spLocks noGrp="1"/>
           </p:cNvSpPr>
@@ -2860,18 +2531,13 @@
               <a:rPr lang="zh-CN" altLang="en-US"/>
               <a:t>五级</a:t>
             </a:r>
-          </a:p>
-        </p:txBody>
-      </p:sp>
-      <p:sp>
-        <p:nvSpPr>
-          <p:cNvPr id="4" name="日期占位符 3">
-            <a:extLst>
-              <a:ext uri="{FF2B5EF4-FFF2-40B4-BE49-F238E27FC236}">
-                <a16:creationId xmlns:a16="http://schemas.microsoft.com/office/drawing/2014/main" id="{63F36961-F4B6-BB2D-4D43-7590175284D8}"/>
-              </a:ext>
-            </a:extLst>
-          </p:cNvPr>
+            <a:endParaRPr lang="en-US" dirty="0"/>
+          </a:p>
+        </p:txBody>
+      </p:sp>
+      <p:sp>
+        <p:nvSpPr>
+          <p:cNvPr id="4" name="Date Placeholder 3"/>
           <p:cNvSpPr>
             <a:spLocks noGrp="1"/>
           </p:cNvSpPr>
@@ -2895,7 +2561,7 @@
               <a:defRPr sz="1200">
                 <a:solidFill>
                   <a:schemeClr val="tx1">
-                    <a:tint val="82000"/>
+                    <a:tint val="75000"/>
                   </a:schemeClr>
                 </a:solidFill>
               </a:defRPr>
@@ -2904,7 +2570,7 @@
           <a:p>
             <a:fld id="{16165D88-AD7F-4A3E-AF0D-D47865DDC7CF}" type="datetimeFigureOut">
               <a:rPr lang="zh-CN" altLang="en-US" smtClean="0"/>
-              <a:t>2026/5/8</a:t>
+              <a:t>2026/5/29</a:t>
             </a:fld>
             <a:endParaRPr lang="zh-CN" altLang="en-US"/>
           </a:p>
@@ -2912,13 +2578,7 @@
       </p:sp>
       <p:sp>
         <p:nvSpPr>
-          <p:cNvPr id="5" name="页脚占位符 4">
-            <a:extLst>
-              <a:ext uri="{FF2B5EF4-FFF2-40B4-BE49-F238E27FC236}">
-                <a16:creationId xmlns:a16="http://schemas.microsoft.com/office/drawing/2014/main" id="{C39F1722-A1D1-E561-7D4C-B9668ED3695D}"/>
-              </a:ext>
-            </a:extLst>
-          </p:cNvPr>
+          <p:cNvPr id="5" name="Footer Placeholder 4"/>
           <p:cNvSpPr>
             <a:spLocks noGrp="1"/>
           </p:cNvSpPr>
@@ -2942,7 +2602,7 @@
               <a:defRPr sz="1200">
                 <a:solidFill>
                   <a:schemeClr val="tx1">
-                    <a:tint val="82000"/>
+                    <a:tint val="75000"/>
                   </a:schemeClr>
                 </a:solidFill>
               </a:defRPr>
@@ -2955,13 +2615,7 @@
       </p:sp>
       <p:sp>
         <p:nvSpPr>
-          <p:cNvPr id="6" name="灯片编号占位符 5">
-            <a:extLst>
-              <a:ext uri="{FF2B5EF4-FFF2-40B4-BE49-F238E27FC236}">
-                <a16:creationId xmlns:a16="http://schemas.microsoft.com/office/drawing/2014/main" id="{63B3C963-613A-345D-C7D2-7E291B80833F}"/>
-              </a:ext>
-            </a:extLst>
-          </p:cNvPr>
+          <p:cNvPr id="6" name="Slide Number Placeholder 5"/>
           <p:cNvSpPr>
             <a:spLocks noGrp="1"/>
           </p:cNvSpPr>
@@ -2985,7 +2639,7 @@
               <a:defRPr sz="1200">
                 <a:solidFill>
                   <a:schemeClr val="tx1">
-                    <a:tint val="82000"/>
+                    <a:tint val="75000"/>
                   </a:schemeClr>
                 </a:solidFill>
               </a:defRPr>
@@ -3003,23 +2657,23 @@
     </p:spTree>
     <p:extLst>
       <p:ext uri="{BB962C8B-B14F-4D97-AF65-F5344CB8AC3E}">
-        <p14:creationId xmlns:p14="http://schemas.microsoft.com/office/powerpoint/2010/main" val="144195304"/>
+        <p14:creationId xmlns:p14="http://schemas.microsoft.com/office/powerpoint/2010/main" val="1913932186"/>
       </p:ext>
     </p:extLst>
   </p:cSld>
   <p:clrMap bg1="lt1" tx1="dk1" bg2="lt2" tx2="dk2" accent1="accent1" accent2="accent2" accent3="accent3" accent4="accent4" accent5="accent5" accent6="accent6" hlink="hlink" folHlink="folHlink"/>
   <p:sldLayoutIdLst>
-    <p:sldLayoutId id="2147483649" r:id="rId1"/>
-    <p:sldLayoutId id="2147483650" r:id="rId2"/>
-    <p:sldLayoutId id="2147483651" r:id="rId3"/>
-    <p:sldLayoutId id="2147483652" r:id="rId4"/>
-    <p:sldLayoutId id="2147483653" r:id="rId5"/>
-    <p:sldLayoutId id="2147483654" r:id="rId6"/>
-    <p:sldLayoutId id="2147483655" r:id="rId7"/>
-    <p:sldLayoutId id="2147483656" r:id="rId8"/>
-    <p:sldLayoutId id="2147483657" r:id="rId9"/>
-    <p:sldLayoutId id="2147483658" r:id="rId10"/>
-    <p:sldLayoutId id="2147483659" r:id="rId11"/>
+    <p:sldLayoutId id="2147483673" r:id="rId1"/>
+    <p:sldLayoutId id="2147483674" r:id="rId2"/>
+    <p:sldLayoutId id="2147483675" r:id="rId3"/>
+    <p:sldLayoutId id="2147483676" r:id="rId4"/>
+    <p:sldLayoutId id="2147483677" r:id="rId5"/>
+    <p:sldLayoutId id="2147483678" r:id="rId6"/>
+    <p:sldLayoutId id="2147483679" r:id="rId7"/>
+    <p:sldLayoutId id="2147483680" r:id="rId8"/>
+    <p:sldLayoutId id="2147483681" r:id="rId9"/>
+    <p:sldLayoutId id="2147483682" r:id="rId10"/>
+    <p:sldLayoutId id="2147483683" r:id="rId11"/>
   </p:sldLayoutIdLst>
   <p:txStyles>
     <p:titleStyle>
@@ -3207,7 +2861,7 @@
     </p:bodyStyle>
     <p:otherStyle>
       <a:defPPr>
-        <a:defRPr lang="zh-CN"/>
+        <a:defRPr lang="en-US"/>
       </a:defPPr>
       <a:lvl1pPr marL="0" algn="l" defTabSz="914400" rtl="0" eaLnBrk="1" latinLnBrk="0" hangingPunct="1">
         <a:defRPr sz="1800" kern="1200">
@@ -3323,10 +2977,65 @@
       </p:grpSpPr>
       <p:sp>
         <p:nvSpPr>
-          <p:cNvPr id="4" name="文本框 3">
+          <p:cNvPr id="2" name="矩形 1">
             <a:extLst>
               <a:ext uri="{FF2B5EF4-FFF2-40B4-BE49-F238E27FC236}">
-                <a16:creationId xmlns:a16="http://schemas.microsoft.com/office/drawing/2014/main" id="{6A3C5B9D-D090-4852-042B-7F7B65AB3843}"/>
+                <a16:creationId xmlns:a16="http://schemas.microsoft.com/office/drawing/2014/main" id="{4A38EA5D-0FC1-2216-79ED-000F8EFC297B}"/>
+              </a:ext>
+            </a:extLst>
+          </p:cNvPr>
+          <p:cNvSpPr/>
+          <p:nvPr/>
+        </p:nvSpPr>
+        <p:spPr>
+          <a:xfrm>
+            <a:off x="180974" y="266700"/>
+            <a:ext cx="10963275" cy="642938"/>
+          </a:xfrm>
+          <a:prstGeom prst="rect">
+            <a:avLst/>
+          </a:prstGeom>
+          <a:solidFill>
+            <a:schemeClr val="tx2">
+              <a:lumMod val="10000"/>
+              <a:lumOff val="90000"/>
+            </a:schemeClr>
+          </a:solidFill>
+          <a:ln>
+            <a:noFill/>
+          </a:ln>
+        </p:spPr>
+        <p:style>
+          <a:lnRef idx="2">
+            <a:schemeClr val="accent1">
+              <a:shade val="15000"/>
+            </a:schemeClr>
+          </a:lnRef>
+          <a:fillRef idx="1">
+            <a:schemeClr val="accent1"/>
+          </a:fillRef>
+          <a:effectRef idx="0">
+            <a:schemeClr val="accent1"/>
+          </a:effectRef>
+          <a:fontRef idx="minor">
+            <a:schemeClr val="lt1"/>
+          </a:fontRef>
+        </p:style>
+        <p:txBody>
+          <a:bodyPr rtlCol="0" anchor="ctr"/>
+          <a:lstStyle/>
+          <a:p>
+            <a:pPr algn="ctr"/>
+            <a:endParaRPr lang="zh-CN" altLang="en-US"/>
+          </a:p>
+        </p:txBody>
+      </p:sp>
+      <p:sp>
+        <p:nvSpPr>
+          <p:cNvPr id="8" name="文本框 7">
+            <a:extLst>
+              <a:ext uri="{FF2B5EF4-FFF2-40B4-BE49-F238E27FC236}">
+                <a16:creationId xmlns:a16="http://schemas.microsoft.com/office/drawing/2014/main" id="{50F21C34-359B-C3C9-C6EB-A716438EE818}"/>
               </a:ext>
             </a:extLst>
           </p:cNvPr>
@@ -3335,8 +3044,8 @@
         </p:nvSpPr>
         <p:spPr>
           <a:xfrm>
-            <a:off x="628450" y="2391577"/>
-            <a:ext cx="10528726" cy="1200329"/>
+            <a:off x="8126768" y="461963"/>
+            <a:ext cx="3201517" cy="369332"/>
           </a:xfrm>
           <a:prstGeom prst="rect">
             <a:avLst/>
@@ -3344,124 +3053,28 @@
           <a:noFill/>
         </p:spPr>
         <p:txBody>
-          <a:bodyPr wrap="square" rtlCol="0">
+          <a:bodyPr wrap="none" rtlCol="0">
             <a:spAutoFit/>
           </a:bodyPr>
           <a:lstStyle/>
           <a:p>
-            <a:pPr marL="342900" indent="-342900">
-              <a:buAutoNum type="arabicPeriod"/>
-            </a:pPr>
+            <a:r>
+              <a:rPr lang="en-US" altLang="zh-CN" dirty="0"/>
+              <a:t>LLM </a:t>
+            </a:r>
             <a:r>
               <a:rPr lang="zh-CN" altLang="en-US" dirty="0"/>
-              <a:t>（做哪些开源数据库</a:t>
-            </a:r>
-            <a:r>
-              <a:rPr lang="en-US" altLang="zh-CN" dirty="0"/>
-              <a:t>/</a:t>
-            </a:r>
-            <a:r>
-              <a:rPr lang="zh-CN" altLang="en-US" dirty="0"/>
-              <a:t>内部数据）选几个数据集写一个简单的描述（名称、字段含义、覆盖时间、</a:t>
-            </a:r>
-            <a:r>
-              <a:rPr lang="en-US" altLang="zh-CN" dirty="0"/>
-              <a:t>API </a:t>
-            </a:r>
-            <a:r>
-              <a:rPr lang="zh-CN" altLang="en-US" dirty="0"/>
-              <a:t>地址），把这些描述存入 向量数据库</a:t>
-            </a:r>
-            <a:endParaRPr lang="en-US" altLang="zh-CN" dirty="0"/>
-          </a:p>
-          <a:p>
-            <a:pPr marL="342900" indent="-342900">
-              <a:buAutoNum type="arabicPeriod"/>
-            </a:pPr>
-            <a:r>
-              <a:rPr lang="zh-CN" altLang="en-US" dirty="0"/>
-              <a:t>尝试使用 </a:t>
-            </a:r>
-            <a:r>
-              <a:rPr lang="en-US" altLang="zh-CN" dirty="0" err="1"/>
-              <a:t>LangChain</a:t>
-            </a:r>
-            <a:r>
-              <a:rPr lang="en-US" altLang="zh-CN" dirty="0"/>
-              <a:t> </a:t>
-            </a:r>
-            <a:r>
-              <a:rPr lang="zh-CN" altLang="en-US" dirty="0"/>
-              <a:t>的 </a:t>
-            </a:r>
-            <a:r>
-              <a:rPr lang="en-US" altLang="zh-CN" dirty="0"/>
-              <a:t>Self-Querying Retriever</a:t>
-            </a:r>
-            <a:r>
-              <a:rPr lang="zh-CN" altLang="en-US" dirty="0"/>
-              <a:t> 功能测试数据检索和回答，返回相关的 </a:t>
-            </a:r>
-            <a:r>
-              <a:rPr lang="en-US" altLang="zh-CN" dirty="0"/>
-              <a:t>API </a:t>
-            </a:r>
-            <a:r>
-              <a:rPr lang="zh-CN" altLang="en-US" dirty="0"/>
-              <a:t>链接。</a:t>
-            </a:r>
-            <a:endParaRPr lang="en-US" altLang="zh-CN" dirty="0"/>
-          </a:p>
-          <a:p>
-            <a:pPr marL="342900" indent="-342900">
-              <a:buAutoNum type="arabicPeriod"/>
-            </a:pPr>
-            <a:r>
-              <a:rPr lang="zh-CN" altLang="en-US" dirty="0"/>
-              <a:t>定义一些 </a:t>
-            </a:r>
-            <a:r>
-              <a:rPr lang="en-US" altLang="zh-CN" dirty="0"/>
-              <a:t>Python </a:t>
-            </a:r>
-            <a:r>
-              <a:rPr lang="zh-CN" altLang="en-US" dirty="0"/>
-              <a:t>函数，使用 </a:t>
-            </a:r>
-            <a:r>
-              <a:rPr lang="en-US" altLang="zh-CN" dirty="0" err="1"/>
-              <a:t>LangChain</a:t>
-            </a:r>
-            <a:r>
-              <a:rPr lang="en-US" altLang="zh-CN" dirty="0"/>
-              <a:t> </a:t>
-            </a:r>
-            <a:r>
-              <a:rPr lang="zh-CN" altLang="en-US" dirty="0"/>
-              <a:t>的 </a:t>
-            </a:r>
-            <a:r>
-              <a:rPr lang="en-US" altLang="zh-CN" dirty="0" err="1"/>
-              <a:t>AgentExecutor</a:t>
-            </a:r>
-            <a:r>
-              <a:rPr lang="zh-CN" altLang="en-US" dirty="0"/>
-              <a:t>专门负责根据参数调用开源 </a:t>
-            </a:r>
-            <a:r>
-              <a:rPr lang="en-US" altLang="zh-CN" dirty="0"/>
-              <a:t>API </a:t>
-            </a:r>
-            <a:endParaRPr lang="zh-CN" altLang="en-US" dirty="0"/>
-          </a:p>
-        </p:txBody>
-      </p:sp>
-      <p:sp>
-        <p:nvSpPr>
-          <p:cNvPr id="5" name="文本框 4">
+              <a:t>负责理解需求和编排工具</a:t>
+            </a:r>
+          </a:p>
+        </p:txBody>
+      </p:sp>
+      <p:sp>
+        <p:nvSpPr>
+          <p:cNvPr id="6" name="文本框 5">
             <a:extLst>
               <a:ext uri="{FF2B5EF4-FFF2-40B4-BE49-F238E27FC236}">
-                <a16:creationId xmlns:a16="http://schemas.microsoft.com/office/drawing/2014/main" id="{65064B08-1DB2-9D6C-1BE4-099BF91E5ABB}"/>
+                <a16:creationId xmlns:a16="http://schemas.microsoft.com/office/drawing/2014/main" id="{97106CA5-FA4F-6EC4-F203-C020701F07DB}"/>
               </a:ext>
             </a:extLst>
           </p:cNvPr>
@@ -3470,8 +3083,8 @@
         </p:nvSpPr>
         <p:spPr>
           <a:xfrm>
-            <a:off x="576063" y="491339"/>
-            <a:ext cx="10528726" cy="646331"/>
+            <a:off x="247451" y="307240"/>
+            <a:ext cx="10528726" cy="1754326"/>
           </a:xfrm>
           <a:prstGeom prst="rect">
             <a:avLst/>
@@ -3489,24 +3102,120 @@
             </a:pPr>
             <a:r>
               <a:rPr lang="zh-CN" altLang="en-US" dirty="0"/>
-              <a:t>任务：对指定的数据库构建</a:t>
+              <a:t>地理编码工具：通过</a:t>
+            </a:r>
+            <a:r>
+              <a:rPr lang="en-US" altLang="zh-CN" dirty="0" err="1"/>
+              <a:t>Geopy</a:t>
+            </a:r>
+            <a:r>
+              <a:rPr lang="zh-CN" altLang="en-US" dirty="0"/>
+              <a:t>实现把语义的位置范围转化为</a:t>
             </a:r>
             <a:r>
               <a:rPr lang="en-US" altLang="zh-CN" dirty="0"/>
-              <a:t>Agent</a:t>
+              <a:t>BBOX</a:t>
             </a:r>
             <a:r>
               <a:rPr lang="zh-CN" altLang="en-US" dirty="0"/>
-              <a:t>，例如  希望做</a:t>
+              <a:t>（经纬度象限）</a:t>
+            </a:r>
+            <a:endParaRPr lang="en-US" altLang="zh-CN" dirty="0"/>
+          </a:p>
+          <a:p>
+            <a:pPr marL="342900" indent="-342900">
+              <a:buFontTx/>
+              <a:buAutoNum type="arabicPeriod"/>
+            </a:pPr>
+            <a:r>
+              <a:rPr lang="zh-CN" altLang="en-US" dirty="0"/>
+              <a:t>调用写好的数据获取工具，模型自己决策用哪一个</a:t>
+            </a:r>
+            <a:endParaRPr lang="en-US" altLang="zh-CN" dirty="0"/>
+          </a:p>
+          <a:p>
+            <a:pPr marL="342900" indent="-342900">
+              <a:buAutoNum type="arabicPeriod"/>
+            </a:pPr>
+            <a:r>
+              <a:rPr lang="zh-CN" altLang="en-US" dirty="0"/>
+              <a:t>数据获取：分为</a:t>
             </a:r>
             <a:r>
               <a:rPr lang="en-US" altLang="zh-CN" dirty="0"/>
-              <a:t>2024</a:t>
+              <a:t>API</a:t>
             </a:r>
             <a:r>
               <a:rPr lang="zh-CN" altLang="en-US" dirty="0"/>
-              <a:t>年中欧碳排放贸易量计算有哪些数据可用，并给出数据</a:t>
-            </a:r>
+              <a:t>请求的和本地数据</a:t>
+            </a:r>
+            <a:endParaRPr lang="en-US" altLang="zh-CN" dirty="0"/>
+          </a:p>
+          <a:p>
+            <a:pPr marL="800100" lvl="1" indent="-342900">
+              <a:buAutoNum type="arabicPeriod"/>
+            </a:pPr>
+            <a:r>
+              <a:rPr lang="en-US" altLang="zh-CN" dirty="0"/>
+              <a:t>API</a:t>
+            </a:r>
+            <a:r>
+              <a:rPr lang="zh-CN" altLang="en-US" dirty="0"/>
+              <a:t>数据每类</a:t>
+            </a:r>
+            <a:r>
+              <a:rPr lang="en-US" altLang="zh-CN" dirty="0"/>
+              <a:t>API</a:t>
+            </a:r>
+            <a:r>
+              <a:rPr lang="zh-CN" altLang="en-US" dirty="0"/>
+              <a:t>一个脚本工具。</a:t>
+            </a:r>
+            <a:endParaRPr lang="en-US" altLang="zh-CN" dirty="0"/>
+          </a:p>
+          <a:p>
+            <a:pPr marL="800100" lvl="1" indent="-342900">
+              <a:buAutoNum type="arabicPeriod"/>
+            </a:pPr>
+            <a:r>
+              <a:rPr lang="zh-CN" altLang="en-US" dirty="0"/>
+              <a:t>本地数据通过</a:t>
+            </a:r>
+            <a:r>
+              <a:rPr lang="en-US" altLang="zh-CN" dirty="0" err="1"/>
+              <a:t>PostGIS</a:t>
+            </a:r>
+            <a:r>
+              <a:rPr lang="en-US" altLang="zh-CN" dirty="0"/>
+              <a:t>/</a:t>
+            </a:r>
+            <a:r>
+              <a:rPr lang="en-US" altLang="zh-CN" dirty="0" err="1"/>
+              <a:t>GeoPandas</a:t>
+            </a:r>
+            <a:r>
+              <a:rPr lang="zh-CN" altLang="en-US" dirty="0"/>
+              <a:t>管理，用</a:t>
+            </a:r>
+            <a:r>
+              <a:rPr lang="en-US" altLang="zh-CN" dirty="0"/>
+              <a:t>SQL</a:t>
+            </a:r>
+            <a:r>
+              <a:rPr lang="zh-CN" altLang="en-US" dirty="0"/>
+              <a:t>语句实现查询和裁剪</a:t>
+            </a:r>
+            <a:endParaRPr lang="en-US" altLang="zh-CN" dirty="0"/>
+          </a:p>
+          <a:p>
+            <a:pPr marL="342900" indent="-342900">
+              <a:buAutoNum type="arabicPeriod"/>
+            </a:pPr>
+            <a:r>
+              <a:rPr lang="zh-CN" altLang="en-US" dirty="0"/>
+              <a:t>标准化输出</a:t>
+            </a:r>
+            <a:endParaRPr lang="en-US" altLang="zh-CN" dirty="0"/>
           </a:p>
         </p:txBody>
       </p:sp>
@@ -3523,10 +3232,805 @@
 </p:sld>
 </file>
 
+<file path=ppt/slides/slide2.xml><?xml version="1.0" encoding="utf-8"?>
+<p:sld xmlns:a="http://schemas.openxmlformats.org/drawingml/2006/main" xmlns:r="http://schemas.openxmlformats.org/officeDocument/2006/relationships" xmlns:p="http://schemas.openxmlformats.org/presentationml/2006/main">
+  <p:cSld>
+    <p:spTree>
+      <p:nvGrpSpPr>
+        <p:cNvPr id="1" name=""/>
+        <p:cNvGrpSpPr/>
+        <p:nvPr/>
+      </p:nvGrpSpPr>
+      <p:grpSpPr>
+        <a:xfrm>
+          <a:off x="0" y="0"/>
+          <a:ext cx="0" cy="0"/>
+          <a:chOff x="0" y="0"/>
+          <a:chExt cx="0" cy="0"/>
+        </a:xfrm>
+      </p:grpSpPr>
+      <p:sp>
+        <p:nvSpPr>
+          <p:cNvPr id="2" name="矩形 1">
+            <a:extLst>
+              <a:ext uri="{FF2B5EF4-FFF2-40B4-BE49-F238E27FC236}">
+                <a16:creationId xmlns:a16="http://schemas.microsoft.com/office/drawing/2014/main" id="{6D80E6C4-DFD0-AE31-044C-E9692E2F05E9}"/>
+              </a:ext>
+            </a:extLst>
+          </p:cNvPr>
+          <p:cNvSpPr/>
+          <p:nvPr/>
+        </p:nvSpPr>
+        <p:spPr>
+          <a:xfrm>
+            <a:off x="1788318" y="2276146"/>
+            <a:ext cx="1757363" cy="723900"/>
+          </a:xfrm>
+          <a:prstGeom prst="rect">
+            <a:avLst/>
+          </a:prstGeom>
+          <a:solidFill>
+            <a:schemeClr val="bg2"/>
+          </a:solidFill>
+          <a:ln w="12700">
+            <a:solidFill>
+              <a:schemeClr val="tx1"/>
+            </a:solidFill>
+          </a:ln>
+        </p:spPr>
+        <p:style>
+          <a:lnRef idx="2">
+            <a:schemeClr val="accent1">
+              <a:shade val="15000"/>
+            </a:schemeClr>
+          </a:lnRef>
+          <a:fillRef idx="1">
+            <a:schemeClr val="accent1"/>
+          </a:fillRef>
+          <a:effectRef idx="0">
+            <a:schemeClr val="accent1"/>
+          </a:effectRef>
+          <a:fontRef idx="minor">
+            <a:schemeClr val="lt1"/>
+          </a:fontRef>
+        </p:style>
+        <p:txBody>
+          <a:bodyPr rtlCol="0" anchor="ctr"/>
+          <a:lstStyle/>
+          <a:p>
+            <a:pPr algn="ctr"/>
+            <a:r>
+              <a:rPr lang="zh-CN" altLang="en-US" dirty="0">
+                <a:solidFill>
+                  <a:sysClr val="windowText" lastClr="000000"/>
+                </a:solidFill>
+              </a:rPr>
+              <a:t>地理编码</a:t>
+            </a:r>
+          </a:p>
+        </p:txBody>
+      </p:sp>
+      <p:sp>
+        <p:nvSpPr>
+          <p:cNvPr id="3" name="矩形 2">
+            <a:extLst>
+              <a:ext uri="{FF2B5EF4-FFF2-40B4-BE49-F238E27FC236}">
+                <a16:creationId xmlns:a16="http://schemas.microsoft.com/office/drawing/2014/main" id="{BD79A9EE-FF9C-1F49-1E2E-851617043C5F}"/>
+              </a:ext>
+            </a:extLst>
+          </p:cNvPr>
+          <p:cNvSpPr/>
+          <p:nvPr/>
+        </p:nvSpPr>
+        <p:spPr>
+          <a:xfrm>
+            <a:off x="4157661" y="2152321"/>
+            <a:ext cx="1757363" cy="971550"/>
+          </a:xfrm>
+          <a:prstGeom prst="rect">
+            <a:avLst/>
+          </a:prstGeom>
+          <a:solidFill>
+            <a:schemeClr val="bg2"/>
+          </a:solidFill>
+          <a:ln w="12700">
+            <a:solidFill>
+              <a:schemeClr val="tx1"/>
+            </a:solidFill>
+          </a:ln>
+        </p:spPr>
+        <p:style>
+          <a:lnRef idx="2">
+            <a:schemeClr val="accent1">
+              <a:shade val="15000"/>
+            </a:schemeClr>
+          </a:lnRef>
+          <a:fillRef idx="1">
+            <a:schemeClr val="accent1"/>
+          </a:fillRef>
+          <a:effectRef idx="0">
+            <a:schemeClr val="accent1"/>
+          </a:effectRef>
+          <a:fontRef idx="minor">
+            <a:schemeClr val="lt1"/>
+          </a:fontRef>
+        </p:style>
+        <p:txBody>
+          <a:bodyPr rtlCol="0" anchor="ctr"/>
+          <a:lstStyle/>
+          <a:p>
+            <a:pPr algn="ctr"/>
+            <a:r>
+              <a:rPr lang="zh-CN" altLang="en-US" dirty="0">
+                <a:solidFill>
+                  <a:sysClr val="windowText" lastClr="000000"/>
+                </a:solidFill>
+              </a:rPr>
+              <a:t>解析出经纬度坐标、年份、搜索半径</a:t>
+            </a:r>
+          </a:p>
+        </p:txBody>
+      </p:sp>
+      <p:sp>
+        <p:nvSpPr>
+          <p:cNvPr id="4" name="流程图: 文档 3">
+            <a:extLst>
+              <a:ext uri="{FF2B5EF4-FFF2-40B4-BE49-F238E27FC236}">
+                <a16:creationId xmlns:a16="http://schemas.microsoft.com/office/drawing/2014/main" id="{19484D9C-9AD2-CFA4-1C4D-905300D345D0}"/>
+              </a:ext>
+            </a:extLst>
+          </p:cNvPr>
+          <p:cNvSpPr/>
+          <p:nvPr/>
+        </p:nvSpPr>
+        <p:spPr>
+          <a:xfrm>
+            <a:off x="1966912" y="933451"/>
+            <a:ext cx="1400175" cy="766762"/>
+          </a:xfrm>
+          <a:prstGeom prst="flowChartDocument">
+            <a:avLst/>
+          </a:prstGeom>
+          <a:solidFill>
+            <a:schemeClr val="bg2"/>
+          </a:solidFill>
+          <a:ln w="12700">
+            <a:solidFill>
+              <a:schemeClr val="tx1"/>
+            </a:solidFill>
+          </a:ln>
+        </p:spPr>
+        <p:style>
+          <a:lnRef idx="2">
+            <a:schemeClr val="accent1">
+              <a:shade val="15000"/>
+            </a:schemeClr>
+          </a:lnRef>
+          <a:fillRef idx="1">
+            <a:schemeClr val="accent1"/>
+          </a:fillRef>
+          <a:effectRef idx="0">
+            <a:schemeClr val="accent1"/>
+          </a:effectRef>
+          <a:fontRef idx="minor">
+            <a:schemeClr val="lt1"/>
+          </a:fontRef>
+        </p:style>
+        <p:txBody>
+          <a:bodyPr rtlCol="0" anchor="ctr"/>
+          <a:lstStyle/>
+          <a:p>
+            <a:pPr algn="ctr"/>
+            <a:r>
+              <a:rPr lang="zh-CN" altLang="en-US" dirty="0">
+                <a:solidFill>
+                  <a:sysClr val="windowText" lastClr="000000"/>
+                </a:solidFill>
+              </a:rPr>
+              <a:t>用户需求</a:t>
+            </a:r>
+          </a:p>
+        </p:txBody>
+      </p:sp>
+      <p:sp>
+        <p:nvSpPr>
+          <p:cNvPr id="5" name="矩形 4">
+            <a:extLst>
+              <a:ext uri="{FF2B5EF4-FFF2-40B4-BE49-F238E27FC236}">
+                <a16:creationId xmlns:a16="http://schemas.microsoft.com/office/drawing/2014/main" id="{ED9D2BC6-0A12-F397-4407-A29ADBE8C294}"/>
+              </a:ext>
+            </a:extLst>
+          </p:cNvPr>
+          <p:cNvSpPr/>
+          <p:nvPr/>
+        </p:nvSpPr>
+        <p:spPr>
+          <a:xfrm>
+            <a:off x="7646193" y="2276146"/>
+            <a:ext cx="1757363" cy="723900"/>
+          </a:xfrm>
+          <a:prstGeom prst="rect">
+            <a:avLst/>
+          </a:prstGeom>
+          <a:solidFill>
+            <a:schemeClr val="bg2"/>
+          </a:solidFill>
+          <a:ln w="12700">
+            <a:solidFill>
+              <a:schemeClr val="tx1"/>
+            </a:solidFill>
+          </a:ln>
+        </p:spPr>
+        <p:style>
+          <a:lnRef idx="2">
+            <a:schemeClr val="accent1">
+              <a:shade val="15000"/>
+            </a:schemeClr>
+          </a:lnRef>
+          <a:fillRef idx="1">
+            <a:schemeClr val="accent1"/>
+          </a:fillRef>
+          <a:effectRef idx="0">
+            <a:schemeClr val="accent1"/>
+          </a:effectRef>
+          <a:fontRef idx="minor">
+            <a:schemeClr val="lt1"/>
+          </a:fontRef>
+        </p:style>
+        <p:txBody>
+          <a:bodyPr rtlCol="0" anchor="ctr"/>
+          <a:lstStyle/>
+          <a:p>
+            <a:pPr algn="ctr"/>
+            <a:r>
+              <a:rPr lang="zh-CN" altLang="en-US" dirty="0">
+                <a:solidFill>
+                  <a:sysClr val="windowText" lastClr="000000"/>
+                </a:solidFill>
+              </a:rPr>
+              <a:t>模型决策调用工具</a:t>
+            </a:r>
+          </a:p>
+        </p:txBody>
+      </p:sp>
+      <p:sp>
+        <p:nvSpPr>
+          <p:cNvPr id="11" name="流程图: 文档 10">
+            <a:extLst>
+              <a:ext uri="{FF2B5EF4-FFF2-40B4-BE49-F238E27FC236}">
+                <a16:creationId xmlns:a16="http://schemas.microsoft.com/office/drawing/2014/main" id="{3C8AF9BD-6487-D8C3-BC96-CD6D3E9160DA}"/>
+              </a:ext>
+            </a:extLst>
+          </p:cNvPr>
+          <p:cNvSpPr/>
+          <p:nvPr/>
+        </p:nvSpPr>
+        <p:spPr>
+          <a:xfrm>
+            <a:off x="7387825" y="933450"/>
+            <a:ext cx="2274097" cy="766763"/>
+          </a:xfrm>
+          <a:prstGeom prst="flowChartDocument">
+            <a:avLst/>
+          </a:prstGeom>
+          <a:solidFill>
+            <a:schemeClr val="bg2"/>
+          </a:solidFill>
+          <a:ln w="12700">
+            <a:solidFill>
+              <a:schemeClr val="tx1"/>
+            </a:solidFill>
+          </a:ln>
+        </p:spPr>
+        <p:style>
+          <a:lnRef idx="2">
+            <a:schemeClr val="accent1">
+              <a:shade val="15000"/>
+            </a:schemeClr>
+          </a:lnRef>
+          <a:fillRef idx="1">
+            <a:schemeClr val="accent1"/>
+          </a:fillRef>
+          <a:effectRef idx="0">
+            <a:schemeClr val="accent1"/>
+          </a:effectRef>
+          <a:fontRef idx="minor">
+            <a:schemeClr val="lt1"/>
+          </a:fontRef>
+        </p:style>
+        <p:txBody>
+          <a:bodyPr rtlCol="0" anchor="ctr"/>
+          <a:lstStyle/>
+          <a:p>
+            <a:pPr algn="ctr"/>
+            <a:r>
+              <a:rPr lang="zh-CN" altLang="en-US" dirty="0">
+                <a:solidFill>
+                  <a:sysClr val="windowText" lastClr="000000"/>
+                </a:solidFill>
+              </a:rPr>
+              <a:t>返回对应区域的数据</a:t>
+            </a:r>
+          </a:p>
+        </p:txBody>
+      </p:sp>
+      <p:sp>
+        <p:nvSpPr>
+          <p:cNvPr id="12" name="矩形 11">
+            <a:extLst>
+              <a:ext uri="{FF2B5EF4-FFF2-40B4-BE49-F238E27FC236}">
+                <a16:creationId xmlns:a16="http://schemas.microsoft.com/office/drawing/2014/main" id="{3E86705B-6633-684A-DEC2-C290283D3125}"/>
+              </a:ext>
+            </a:extLst>
+          </p:cNvPr>
+          <p:cNvSpPr/>
+          <p:nvPr/>
+        </p:nvSpPr>
+        <p:spPr>
+          <a:xfrm>
+            <a:off x="5564982" y="3854589"/>
+            <a:ext cx="1757363" cy="1390650"/>
+          </a:xfrm>
+          <a:prstGeom prst="rect">
+            <a:avLst/>
+          </a:prstGeom>
+          <a:solidFill>
+            <a:schemeClr val="bg2"/>
+          </a:solidFill>
+          <a:ln w="12700">
+            <a:solidFill>
+              <a:schemeClr val="tx1"/>
+            </a:solidFill>
+          </a:ln>
+        </p:spPr>
+        <p:style>
+          <a:lnRef idx="2">
+            <a:schemeClr val="accent1">
+              <a:shade val="15000"/>
+            </a:schemeClr>
+          </a:lnRef>
+          <a:fillRef idx="1">
+            <a:schemeClr val="accent1"/>
+          </a:fillRef>
+          <a:effectRef idx="0">
+            <a:schemeClr val="accent1"/>
+          </a:effectRef>
+          <a:fontRef idx="minor">
+            <a:schemeClr val="lt1"/>
+          </a:fontRef>
+        </p:style>
+        <p:txBody>
+          <a:bodyPr rtlCol="0" anchor="ctr"/>
+          <a:lstStyle/>
+          <a:p>
+            <a:pPr algn="ctr"/>
+            <a:r>
+              <a:rPr lang="en-US" altLang="zh-CN" dirty="0">
+                <a:solidFill>
+                  <a:sysClr val="windowText" lastClr="000000"/>
+                </a:solidFill>
+              </a:rPr>
+              <a:t>Validation</a:t>
+            </a:r>
+          </a:p>
+          <a:p>
+            <a:pPr algn="ctr"/>
+            <a:r>
+              <a:rPr lang="en-US" altLang="zh-CN" dirty="0">
+                <a:solidFill>
+                  <a:sysClr val="windowText" lastClr="000000"/>
+                </a:solidFill>
+              </a:rPr>
+              <a:t>Web searching checking</a:t>
+            </a:r>
+            <a:r>
+              <a:rPr lang="zh-CN" altLang="en-US" dirty="0">
+                <a:solidFill>
+                  <a:sysClr val="windowText" lastClr="000000"/>
+                </a:solidFill>
+              </a:rPr>
+              <a:t>，检查经纬度对不对</a:t>
+            </a:r>
+          </a:p>
+        </p:txBody>
+      </p:sp>
+      <p:cxnSp>
+        <p:nvCxnSpPr>
+          <p:cNvPr id="14" name="直接箭头连接符 13">
+            <a:extLst>
+              <a:ext uri="{FF2B5EF4-FFF2-40B4-BE49-F238E27FC236}">
+                <a16:creationId xmlns:a16="http://schemas.microsoft.com/office/drawing/2014/main" id="{F300EF01-1782-02F3-4D2B-1B863F3EBB10}"/>
+              </a:ext>
+            </a:extLst>
+          </p:cNvPr>
+          <p:cNvCxnSpPr>
+            <a:cxnSpLocks/>
+            <a:stCxn id="4" idx="2"/>
+            <a:endCxn id="2" idx="0"/>
+          </p:cNvCxnSpPr>
+          <p:nvPr/>
+        </p:nvCxnSpPr>
+        <p:spPr>
+          <a:xfrm>
+            <a:off x="2667000" y="1649522"/>
+            <a:ext cx="0" cy="626624"/>
+          </a:xfrm>
+          <a:prstGeom prst="straightConnector1">
+            <a:avLst/>
+          </a:prstGeom>
+          <a:ln w="12700">
+            <a:solidFill>
+              <a:schemeClr val="tx1"/>
+            </a:solidFill>
+            <a:tailEnd type="triangle"/>
+          </a:ln>
+        </p:spPr>
+        <p:style>
+          <a:lnRef idx="1">
+            <a:schemeClr val="accent1"/>
+          </a:lnRef>
+          <a:fillRef idx="0">
+            <a:schemeClr val="accent1"/>
+          </a:fillRef>
+          <a:effectRef idx="0">
+            <a:schemeClr val="accent1"/>
+          </a:effectRef>
+          <a:fontRef idx="minor">
+            <a:schemeClr val="tx1"/>
+          </a:fontRef>
+        </p:style>
+      </p:cxnSp>
+      <p:cxnSp>
+        <p:nvCxnSpPr>
+          <p:cNvPr id="17" name="直接箭头连接符 16">
+            <a:extLst>
+              <a:ext uri="{FF2B5EF4-FFF2-40B4-BE49-F238E27FC236}">
+                <a16:creationId xmlns:a16="http://schemas.microsoft.com/office/drawing/2014/main" id="{F6604C9B-8E0C-52C4-2AEB-D87BDCC0E600}"/>
+              </a:ext>
+            </a:extLst>
+          </p:cNvPr>
+          <p:cNvCxnSpPr>
+            <a:stCxn id="2" idx="3"/>
+            <a:endCxn id="3" idx="1"/>
+          </p:cNvCxnSpPr>
+          <p:nvPr/>
+        </p:nvCxnSpPr>
+        <p:spPr>
+          <a:xfrm>
+            <a:off x="3545681" y="2638096"/>
+            <a:ext cx="611980" cy="0"/>
+          </a:xfrm>
+          <a:prstGeom prst="straightConnector1">
+            <a:avLst/>
+          </a:prstGeom>
+          <a:ln w="12700">
+            <a:solidFill>
+              <a:schemeClr val="tx1"/>
+            </a:solidFill>
+            <a:tailEnd type="triangle"/>
+          </a:ln>
+        </p:spPr>
+        <p:style>
+          <a:lnRef idx="1">
+            <a:schemeClr val="accent1"/>
+          </a:lnRef>
+          <a:fillRef idx="0">
+            <a:schemeClr val="accent1"/>
+          </a:fillRef>
+          <a:effectRef idx="0">
+            <a:schemeClr val="accent1"/>
+          </a:effectRef>
+          <a:fontRef idx="minor">
+            <a:schemeClr val="tx1"/>
+          </a:fontRef>
+        </p:style>
+      </p:cxnSp>
+      <p:cxnSp>
+        <p:nvCxnSpPr>
+          <p:cNvPr id="19" name="直接箭头连接符 18">
+            <a:extLst>
+              <a:ext uri="{FF2B5EF4-FFF2-40B4-BE49-F238E27FC236}">
+                <a16:creationId xmlns:a16="http://schemas.microsoft.com/office/drawing/2014/main" id="{BCDACD70-0EF1-2B6C-53B2-F5A8B7763971}"/>
+              </a:ext>
+            </a:extLst>
+          </p:cNvPr>
+          <p:cNvCxnSpPr>
+            <a:stCxn id="3" idx="3"/>
+            <a:endCxn id="5" idx="1"/>
+          </p:cNvCxnSpPr>
+          <p:nvPr/>
+        </p:nvCxnSpPr>
+        <p:spPr>
+          <a:xfrm>
+            <a:off x="5915024" y="2638096"/>
+            <a:ext cx="1731169" cy="0"/>
+          </a:xfrm>
+          <a:prstGeom prst="straightConnector1">
+            <a:avLst/>
+          </a:prstGeom>
+          <a:ln w="12700">
+            <a:solidFill>
+              <a:schemeClr val="tx1"/>
+            </a:solidFill>
+            <a:tailEnd type="triangle"/>
+          </a:ln>
+        </p:spPr>
+        <p:style>
+          <a:lnRef idx="1">
+            <a:schemeClr val="accent1"/>
+          </a:lnRef>
+          <a:fillRef idx="0">
+            <a:schemeClr val="accent1"/>
+          </a:fillRef>
+          <a:effectRef idx="0">
+            <a:schemeClr val="accent1"/>
+          </a:effectRef>
+          <a:fontRef idx="minor">
+            <a:schemeClr val="tx1"/>
+          </a:fontRef>
+        </p:style>
+      </p:cxnSp>
+      <p:cxnSp>
+        <p:nvCxnSpPr>
+          <p:cNvPr id="25" name="连接符: 肘形 24">
+            <a:extLst>
+              <a:ext uri="{FF2B5EF4-FFF2-40B4-BE49-F238E27FC236}">
+                <a16:creationId xmlns:a16="http://schemas.microsoft.com/office/drawing/2014/main" id="{F5198BD1-8916-1844-FFAF-BC30E4396B72}"/>
+              </a:ext>
+            </a:extLst>
+          </p:cNvPr>
+          <p:cNvCxnSpPr>
+            <a:cxnSpLocks/>
+            <a:stCxn id="3" idx="2"/>
+            <a:endCxn id="12" idx="1"/>
+          </p:cNvCxnSpPr>
+          <p:nvPr/>
+        </p:nvCxnSpPr>
+        <p:spPr>
+          <a:xfrm rot="16200000" flipH="1">
+            <a:off x="4587641" y="3572572"/>
+            <a:ext cx="1426043" cy="528639"/>
+          </a:xfrm>
+          <a:prstGeom prst="bentConnector2">
+            <a:avLst/>
+          </a:prstGeom>
+          <a:ln w="12700">
+            <a:solidFill>
+              <a:schemeClr val="tx1"/>
+            </a:solidFill>
+            <a:tailEnd type="triangle"/>
+          </a:ln>
+        </p:spPr>
+        <p:style>
+          <a:lnRef idx="1">
+            <a:schemeClr val="accent1"/>
+          </a:lnRef>
+          <a:fillRef idx="0">
+            <a:schemeClr val="accent1"/>
+          </a:fillRef>
+          <a:effectRef idx="0">
+            <a:schemeClr val="accent1"/>
+          </a:effectRef>
+          <a:fontRef idx="minor">
+            <a:schemeClr val="tx1"/>
+          </a:fontRef>
+        </p:style>
+      </p:cxnSp>
+      <p:cxnSp>
+        <p:nvCxnSpPr>
+          <p:cNvPr id="27" name="连接符: 肘形 26">
+            <a:extLst>
+              <a:ext uri="{FF2B5EF4-FFF2-40B4-BE49-F238E27FC236}">
+                <a16:creationId xmlns:a16="http://schemas.microsoft.com/office/drawing/2014/main" id="{4B7EB3D8-CAD3-C440-2D49-1FAA9837A0A5}"/>
+              </a:ext>
+            </a:extLst>
+          </p:cNvPr>
+          <p:cNvCxnSpPr>
+            <a:cxnSpLocks/>
+            <a:stCxn id="12" idx="3"/>
+            <a:endCxn id="5" idx="1"/>
+          </p:cNvCxnSpPr>
+          <p:nvPr/>
+        </p:nvCxnSpPr>
+        <p:spPr>
+          <a:xfrm flipV="1">
+            <a:off x="7322345" y="2638096"/>
+            <a:ext cx="323848" cy="1911818"/>
+          </a:xfrm>
+          <a:prstGeom prst="bentConnector3">
+            <a:avLst>
+              <a:gd name="adj1" fmla="val 50000"/>
+            </a:avLst>
+          </a:prstGeom>
+          <a:ln w="12700">
+            <a:solidFill>
+              <a:schemeClr val="tx1"/>
+            </a:solidFill>
+            <a:tailEnd type="triangle"/>
+          </a:ln>
+        </p:spPr>
+        <p:style>
+          <a:lnRef idx="1">
+            <a:schemeClr val="accent1"/>
+          </a:lnRef>
+          <a:fillRef idx="0">
+            <a:schemeClr val="accent1"/>
+          </a:fillRef>
+          <a:effectRef idx="0">
+            <a:schemeClr val="accent1"/>
+          </a:effectRef>
+          <a:fontRef idx="minor">
+            <a:schemeClr val="tx1"/>
+          </a:fontRef>
+        </p:style>
+      </p:cxnSp>
+      <p:cxnSp>
+        <p:nvCxnSpPr>
+          <p:cNvPr id="63" name="直接箭头连接符 62">
+            <a:extLst>
+              <a:ext uri="{FF2B5EF4-FFF2-40B4-BE49-F238E27FC236}">
+                <a16:creationId xmlns:a16="http://schemas.microsoft.com/office/drawing/2014/main" id="{8D7A306D-A8B4-0E49-83D9-B45077651DBE}"/>
+              </a:ext>
+            </a:extLst>
+          </p:cNvPr>
+          <p:cNvCxnSpPr>
+            <a:stCxn id="5" idx="0"/>
+            <a:endCxn id="11" idx="2"/>
+          </p:cNvCxnSpPr>
+          <p:nvPr/>
+        </p:nvCxnSpPr>
+        <p:spPr>
+          <a:xfrm flipH="1" flipV="1">
+            <a:off x="8524874" y="1649521"/>
+            <a:ext cx="1" cy="626625"/>
+          </a:xfrm>
+          <a:prstGeom prst="straightConnector1">
+            <a:avLst/>
+          </a:prstGeom>
+          <a:ln w="12700">
+            <a:solidFill>
+              <a:schemeClr val="tx1"/>
+            </a:solidFill>
+            <a:tailEnd type="triangle"/>
+          </a:ln>
+        </p:spPr>
+        <p:style>
+          <a:lnRef idx="1">
+            <a:schemeClr val="accent1"/>
+          </a:lnRef>
+          <a:fillRef idx="0">
+            <a:schemeClr val="accent1"/>
+          </a:fillRef>
+          <a:effectRef idx="0">
+            <a:schemeClr val="accent1"/>
+          </a:effectRef>
+          <a:fontRef idx="minor">
+            <a:schemeClr val="tx1"/>
+          </a:fontRef>
+        </p:style>
+      </p:cxnSp>
+    </p:spTree>
+    <p:extLst>
+      <p:ext uri="{BB962C8B-B14F-4D97-AF65-F5344CB8AC3E}">
+        <p14:creationId xmlns:p14="http://schemas.microsoft.com/office/powerpoint/2010/main" val="590334581"/>
+      </p:ext>
+    </p:extLst>
+  </p:cSld>
+  <p:clrMapOvr>
+    <a:masterClrMapping/>
+  </p:clrMapOvr>
+</p:sld>
+</file>
+
+<file path=ppt/slides/slide3.xml><?xml version="1.0" encoding="utf-8"?>
+<p:sld xmlns:a="http://schemas.openxmlformats.org/drawingml/2006/main" xmlns:r="http://schemas.openxmlformats.org/officeDocument/2006/relationships" xmlns:p="http://schemas.openxmlformats.org/presentationml/2006/main">
+  <p:cSld>
+    <p:spTree>
+      <p:nvGrpSpPr>
+        <p:cNvPr id="1" name="">
+          <a:extLst>
+            <a:ext uri="{FF2B5EF4-FFF2-40B4-BE49-F238E27FC236}">
+              <a16:creationId xmlns:a16="http://schemas.microsoft.com/office/drawing/2014/main" id="{0D881C96-E889-DC8E-AE26-F407EF77C49F}"/>
+            </a:ext>
+          </a:extLst>
+        </p:cNvPr>
+        <p:cNvGrpSpPr/>
+        <p:nvPr/>
+      </p:nvGrpSpPr>
+      <p:grpSpPr>
+        <a:xfrm>
+          <a:off x="0" y="0"/>
+          <a:ext cx="0" cy="0"/>
+          <a:chOff x="0" y="0"/>
+          <a:chExt cx="0" cy="0"/>
+        </a:xfrm>
+      </p:grpSpPr>
+      <p:pic>
+        <p:nvPicPr>
+          <p:cNvPr id="14" name="图片 13">
+            <a:extLst>
+              <a:ext uri="{FF2B5EF4-FFF2-40B4-BE49-F238E27FC236}">
+                <a16:creationId xmlns:a16="http://schemas.microsoft.com/office/drawing/2014/main" id="{1D590B94-9A0E-BF6C-9CAD-2479C10D7012}"/>
+              </a:ext>
+            </a:extLst>
+          </p:cNvPr>
+          <p:cNvPicPr>
+            <a:picLocks noChangeAspect="1"/>
+          </p:cNvPicPr>
+          <p:nvPr/>
+        </p:nvPicPr>
+        <p:blipFill>
+          <a:blip r:embed="rId2"/>
+          <a:stretch>
+            <a:fillRect/>
+          </a:stretch>
+        </p:blipFill>
+        <p:spPr>
+          <a:xfrm>
+            <a:off x="64251" y="2235975"/>
+            <a:ext cx="11358646" cy="5195925"/>
+          </a:xfrm>
+          <a:prstGeom prst="rect">
+            <a:avLst/>
+          </a:prstGeom>
+        </p:spPr>
+      </p:pic>
+      <p:sp>
+        <p:nvSpPr>
+          <p:cNvPr id="4" name="文本框 3">
+            <a:extLst>
+              <a:ext uri="{FF2B5EF4-FFF2-40B4-BE49-F238E27FC236}">
+                <a16:creationId xmlns:a16="http://schemas.microsoft.com/office/drawing/2014/main" id="{FD6B7DD3-F6F4-B638-50BA-421CAF5AD00B}"/>
+              </a:ext>
+            </a:extLst>
+          </p:cNvPr>
+          <p:cNvSpPr txBox="1"/>
+          <p:nvPr/>
+        </p:nvSpPr>
+        <p:spPr>
+          <a:xfrm>
+            <a:off x="247451" y="307240"/>
+            <a:ext cx="10528726" cy="369332"/>
+          </a:xfrm>
+          <a:prstGeom prst="rect">
+            <a:avLst/>
+          </a:prstGeom>
+          <a:noFill/>
+        </p:spPr>
+        <p:txBody>
+          <a:bodyPr wrap="square" rtlCol="0">
+            <a:spAutoFit/>
+          </a:bodyPr>
+          <a:lstStyle/>
+          <a:p>
+            <a:pPr marL="342900" indent="-342900">
+              <a:buAutoNum type="arabicPeriod"/>
+            </a:pPr>
+            <a:r>
+              <a:rPr lang="zh-CN" altLang="en-US" dirty="0"/>
+              <a:t>添加了</a:t>
+            </a:r>
+            <a:endParaRPr lang="en-US" altLang="zh-CN" dirty="0"/>
+          </a:p>
+        </p:txBody>
+      </p:sp>
+    </p:spTree>
+    <p:extLst>
+      <p:ext uri="{BB962C8B-B14F-4D97-AF65-F5344CB8AC3E}">
+        <p14:creationId xmlns:p14="http://schemas.microsoft.com/office/powerpoint/2010/main" val="220296954"/>
+      </p:ext>
+    </p:extLst>
+  </p:cSld>
+  <p:clrMapOvr>
+    <a:masterClrMapping/>
+  </p:clrMapOvr>
+</p:sld>
+</file>
+
 <file path=ppt/theme/theme1.xml><?xml version="1.0" encoding="utf-8"?>
-<a:theme xmlns:a="http://schemas.openxmlformats.org/drawingml/2006/main" name="Office 主题​​">
+<a:theme xmlns:a="http://schemas.openxmlformats.org/drawingml/2006/main" name="Office 2013 - 2022 主题">
   <a:themeElements>
-    <a:clrScheme name="Office">
+    <a:clrScheme name="Office 2013 - 2022 主题">
       <a:dk1>
         <a:sysClr val="windowText" lastClr="000000"/>
       </a:dk1>
@@ -3534,39 +4038,39 @@
         <a:sysClr val="window" lastClr="FFFFFF"/>
       </a:lt1>
       <a:dk2>
-        <a:srgbClr val="0E2841"/>
+        <a:srgbClr val="44546A"/>
       </a:dk2>
       <a:lt2>
-        <a:srgbClr val="E8E8E8"/>
+        <a:srgbClr val="E7E6E6"/>
       </a:lt2>
       <a:accent1>
-        <a:srgbClr val="156082"/>
+        <a:srgbClr val="4472C4"/>
       </a:accent1>
       <a:accent2>
-        <a:srgbClr val="E97132"/>
+        <a:srgbClr val="ED7D31"/>
       </a:accent2>
       <a:accent3>
-        <a:srgbClr val="196B24"/>
+        <a:srgbClr val="A5A5A5"/>
       </a:accent3>
       <a:accent4>
-        <a:srgbClr val="0F9ED5"/>
+        <a:srgbClr val="FFC000"/>
       </a:accent4>
       <a:accent5>
-        <a:srgbClr val="A02B93"/>
+        <a:srgbClr val="5B9BD5"/>
       </a:accent5>
       <a:accent6>
-        <a:srgbClr val="4EA72E"/>
+        <a:srgbClr val="70AD47"/>
       </a:accent6>
       <a:hlink>
-        <a:srgbClr val="467886"/>
+        <a:srgbClr val="0563C1"/>
       </a:hlink>
       <a:folHlink>
-        <a:srgbClr val="96607D"/>
+        <a:srgbClr val="954F72"/>
       </a:folHlink>
     </a:clrScheme>
-    <a:fontScheme name="Office">
+    <a:fontScheme name="Office 2013 - 2022 主题">
       <a:majorFont>
-        <a:latin typeface="等线 Light" panose="02110004020202020204"/>
+        <a:latin typeface="Calibri Light" panose="020F0302020204030204"/>
         <a:ea typeface=""/>
         <a:cs typeface=""/>
         <a:font script="Jpan" typeface="游ゴシック Light"/>
@@ -3599,26 +4103,9 @@
         <a:font script="Viet" typeface="Times New Roman"/>
         <a:font script="Uigh" typeface="Microsoft Uighur"/>
         <a:font script="Geor" typeface="Sylfaen"/>
-        <a:font script="Armn" typeface="Arial"/>
-        <a:font script="Bugi" typeface="Leelawadee UI"/>
-        <a:font script="Bopo" typeface="Microsoft JhengHei"/>
-        <a:font script="Java" typeface="Javanese Text"/>
-        <a:font script="Lisu" typeface="Segoe UI"/>
-        <a:font script="Mymr" typeface="Myanmar Text"/>
-        <a:font script="Nkoo" typeface="Ebrima"/>
-        <a:font script="Olck" typeface="Nirmala UI"/>
-        <a:font script="Osma" typeface="Ebrima"/>
-        <a:font script="Phag" typeface="Phagspa"/>
-        <a:font script="Syrn" typeface="Estrangelo Edessa"/>
-        <a:font script="Syrj" typeface="Estrangelo Edessa"/>
-        <a:font script="Syre" typeface="Estrangelo Edessa"/>
-        <a:font script="Sora" typeface="Nirmala UI"/>
-        <a:font script="Tale" typeface="Microsoft Tai Le"/>
-        <a:font script="Talu" typeface="Microsoft New Tai Lue"/>
-        <a:font script="Tfng" typeface="Ebrima"/>
       </a:majorFont>
       <a:minorFont>
-        <a:latin typeface="等线" panose="02110004020202020204"/>
+        <a:latin typeface="Calibri" panose="020F0502020204030204"/>
         <a:ea typeface=""/>
         <a:cs typeface=""/>
         <a:font script="Jpan" typeface="游ゴシック"/>
@@ -3651,26 +4138,9 @@
         <a:font script="Viet" typeface="Arial"/>
         <a:font script="Uigh" typeface="Microsoft Uighur"/>
         <a:font script="Geor" typeface="Sylfaen"/>
-        <a:font script="Armn" typeface="Arial"/>
-        <a:font script="Bugi" typeface="Leelawadee UI"/>
-        <a:font script="Bopo" typeface="Microsoft JhengHei"/>
-        <a:font script="Java" typeface="Javanese Text"/>
-        <a:font script="Lisu" typeface="Segoe UI"/>
-        <a:font script="Mymr" typeface="Myanmar Text"/>
-        <a:font script="Nkoo" typeface="Ebrima"/>
-        <a:font script="Olck" typeface="Nirmala UI"/>
-        <a:font script="Osma" typeface="Ebrima"/>
-        <a:font script="Phag" typeface="Phagspa"/>
-        <a:font script="Syrn" typeface="Estrangelo Edessa"/>
-        <a:font script="Syrj" typeface="Estrangelo Edessa"/>
-        <a:font script="Syre" typeface="Estrangelo Edessa"/>
-        <a:font script="Sora" typeface="Nirmala UI"/>
-        <a:font script="Tale" typeface="Microsoft Tai Le"/>
-        <a:font script="Talu" typeface="Microsoft New Tai Lue"/>
-        <a:font script="Tfng" typeface="Ebrima"/>
       </a:minorFont>
     </a:fontScheme>
-    <a:fmtScheme name="Office">
+    <a:fmtScheme name="Office 2013 - 2022 主题">
       <a:fillStyleLst>
         <a:solidFill>
           <a:schemeClr val="phClr"/>
@@ -3729,6 +4199,13 @@
         </a:gradFill>
       </a:fillStyleLst>
       <a:lnStyleLst>
+        <a:ln w="6350" cap="flat" cmpd="sng" algn="ctr">
+          <a:solidFill>
+            <a:schemeClr val="phClr"/>
+          </a:solidFill>
+          <a:prstDash val="solid"/>
+          <a:miter lim="800000"/>
+        </a:ln>
         <a:ln w="12700" cap="flat" cmpd="sng" algn="ctr">
           <a:solidFill>
             <a:schemeClr val="phClr"/>
@@ -3737,13 +4214,6 @@
           <a:miter lim="800000"/>
         </a:ln>
         <a:ln w="19050" cap="flat" cmpd="sng" algn="ctr">
-          <a:solidFill>
-            <a:schemeClr val="phClr"/>
-          </a:solidFill>
-          <a:prstDash val="solid"/>
-          <a:miter lim="800000"/>
-        </a:ln>
-        <a:ln w="25400" cap="flat" cmpd="sng" algn="ctr">
           <a:solidFill>
             <a:schemeClr val="phClr"/>
           </a:solidFill>
@@ -3808,31 +4278,11 @@
       </a:bgFillStyleLst>
     </a:fmtScheme>
   </a:themeElements>
-  <a:objectDefaults>
-    <a:lnDef>
-      <a:spPr/>
-      <a:bodyPr/>
-      <a:lstStyle/>
-      <a:style>
-        <a:lnRef idx="2">
-          <a:schemeClr val="accent1"/>
-        </a:lnRef>
-        <a:fillRef idx="0">
-          <a:schemeClr val="accent1"/>
-        </a:fillRef>
-        <a:effectRef idx="1">
-          <a:schemeClr val="accent1"/>
-        </a:effectRef>
-        <a:fontRef idx="minor">
-          <a:schemeClr val="tx1"/>
-        </a:fontRef>
-      </a:style>
-    </a:lnDef>
-  </a:objectDefaults>
+  <a:objectDefaults/>
   <a:extraClrSchemeLst/>
   <a:extLst>
     <a:ext uri="{05A4C25C-085E-4340-85A3-A5531E510DB2}">
-      <thm15:themeFamily xmlns:thm15="http://schemas.microsoft.com/office/thememl/2012/main" name="Office Theme" id="{2E142A2C-CD16-42D6-873A-C26D2A0506FA}" vid="{1BDDFF52-6CD6-40A5-AB3C-68EB2F1E4D0A}"/>
+      <thm15:themeFamily xmlns:thm15="http://schemas.microsoft.com/office/thememl/2012/main" name="Office 2013 - 2022 Theme" id="{62F939B6-93AF-4DB8-9C6B-D6C7DFDC589F}" vid="{4A3C46E8-61CC-4603-A589-7422A47A8E4A}"/>
     </a:ext>
   </a:extLst>
 </a:theme>

</xml_diff>